<commit_message>
Add second real project (S2P_Project.xlsx) to portfolio
</commit_message>
<xml_diff>
--- a/presentation/Monthly_Executive_Update.pptx
+++ b/presentation/Monthly_Executive_Update.pptx
@@ -4,6 +4,9 @@
   <p:sldMasterIdLst>
     <p:sldMasterId id="2147483648" r:id="rId1"/>
   </p:sldMasterIdLst>
+  <p:notesMasterIdLst>
+    <p:notesMasterId r:id="rId8"/>
+  </p:notesMasterIdLst>
   <p:sldIdLst>
     <p:sldId id="256" r:id="rId2"/>
     <p:sldId id="257" r:id="rId3"/>
@@ -12,9 +15,6 @@
     <p:sldId id="260" r:id="rId6"/>
     <p:sldId id="261" r:id="rId7"/>
   </p:sldIdLst>
-  <p:notesMasterIdLst>
-    <p:notesMasterId r:id="rId8"/>
-  </p:notesMasterIdLst>
   <p:sldSz cx="12192000" cy="6858000"/>
   <p:notesSz cx="6858000" cy="12192000"/>
   <p:defaultTextStyle>
@@ -109,13 +109,20 @@
       </a:defRPr>
     </a:lvl9pPr>
   </p:defaultTextStyle>
+  <p:extLst>
+    <p:ext uri="{EFAFB233-063F-42B5-8137-9DF3F51BA10A}">
+      <p15:sldGuideLst xmlns:p15="http://schemas.microsoft.com/office/powerpoint/2012/main"/>
+    </p:ext>
+  </p:extLst>
 </p:presentation>
 </file>
 
 <file path=ppt/charts/chart1.xml><?xml version="1.0" encoding="utf-8"?>
-<c:chartSpace xmlns:c="http://schemas.openxmlformats.org/drawingml/2006/chart" xmlns:a="http://schemas.openxmlformats.org/drawingml/2006/main" xmlns:r="http://schemas.openxmlformats.org/officeDocument/2006/relationships">
+<c:chartSpace xmlns:c="http://schemas.openxmlformats.org/drawingml/2006/chart" xmlns:a="http://schemas.openxmlformats.org/drawingml/2006/main" xmlns:r="http://schemas.openxmlformats.org/officeDocument/2006/relationships" xmlns:c16r2="http://schemas.microsoft.com/office/drawing/2015/06/chart">
   <c:date1904 val="0"/>
+  <c:lang val="en-US"/>
   <c:roundedCorners val="1"/>
+  <c:style val="2"/>
   <c:chart>
     <c:autoTitleDeleted val="1"/>
     <c:plotArea>
@@ -147,18 +154,26 @@
           <c:invertIfNegative val="0"/>
           <c:dLbls>
             <c:numFmt formatCode="#,##0" sourceLinked="0"/>
+            <c:spPr>
+              <a:noFill/>
+              <a:ln>
+                <a:noFill/>
+              </a:ln>
+              <a:effectLst/>
+            </c:spPr>
             <c:txPr>
               <a:bodyPr/>
               <a:lstStyle/>
               <a:p>
                 <a:pPr>
-                  <a:defRPr b="0" i="0" strike="noStrike" sz="1200" u="none">
+                  <a:defRPr sz="1200" b="0" i="0" u="none" strike="noStrike">
                     <a:solidFill>
                       <a:srgbClr val="FFFFFF"/>
                     </a:solidFill>
                     <a:latin typeface="Arial"/>
                   </a:defRPr>
                 </a:pPr>
+                <a:endParaRPr lang="en-US"/>
               </a:p>
             </c:txPr>
             <c:showLegendKey val="0"/>
@@ -168,28 +183,31 @@
             <c:showPercent val="0"/>
             <c:showBubbleSize val="0"/>
             <c:showLeaderLines val="0"/>
+            <c:extLst>
+              <c:ext xmlns:c15="http://schemas.microsoft.com/office/drawing/2012/chart" uri="{CE6537A1-D6FC-4f65-9D91-7224C49458BB}">
+                <c15:showLeaderLines val="0"/>
+              </c:ext>
+            </c:extLst>
           </c:dLbls>
           <c:cat>
-            <c:multiLvlStrRef>
+            <c:strRef>
               <c:f>Sheet1!$A$2:$A$5</c:f>
-              <c:multiLvlStrCache>
+              <c:strCache>
                 <c:ptCount val="4"/>
-                <c:lvl>
-                  <c:pt idx="0">
-                    <c:v>Schedule</c:v>
-                  </c:pt>
-                  <c:pt idx="1">
-                    <c:v>Milestones</c:v>
-                  </c:pt>
-                  <c:pt idx="2">
-                    <c:v>Blockers</c:v>
-                  </c:pt>
-                  <c:pt idx="3">
-                    <c:v>Sentiment</c:v>
-                  </c:pt>
-                </c:lvl>
-              </c:multiLvlStrCache>
-            </c:multiLvlStrRef>
+                <c:pt idx="0">
+                  <c:v>Schedule</c:v>
+                </c:pt>
+                <c:pt idx="1">
+                  <c:v>Milestones</c:v>
+                </c:pt>
+                <c:pt idx="2">
+                  <c:v>Blockers</c:v>
+                </c:pt>
+                <c:pt idx="3">
+                  <c:v>Sentiment</c:v>
+                </c:pt>
+              </c:strCache>
+            </c:strRef>
           </c:cat>
           <c:val>
             <c:numRef>
@@ -198,13 +216,13 @@
                 <c:formatCode>General</c:formatCode>
                 <c:ptCount val="4"/>
                 <c:pt idx="0">
-                  <c:v>3</c:v>
+                  <c:v>4</c:v>
                 </c:pt>
                 <c:pt idx="1">
-                  <c:v>3</c:v>
+                  <c:v>4</c:v>
                 </c:pt>
                 <c:pt idx="2">
-                  <c:v>2</c:v>
+                  <c:v>3</c:v>
                 </c:pt>
                 <c:pt idx="3">
                   <c:v>1</c:v>
@@ -212,36 +230,23 @@
               </c:numCache>
             </c:numRef>
           </c:val>
+          <c:extLst>
+            <c:ext xmlns:c16="http://schemas.microsoft.com/office/drawing/2014/chart" uri="{C3380CC4-5D6E-409C-BE32-E72D297353CC}">
+              <c16:uniqueId val="{00000000-0CE9-46F8-BE03-597BFED7B43E}"/>
+            </c:ext>
+          </c:extLst>
         </c:ser>
         <c:dLbls>
-          <c:numFmt formatCode="#,##0" sourceLinked="0"/>
-          <c:txPr>
-            <a:bodyPr/>
-            <a:lstStyle/>
-            <a:p>
-              <a:pPr>
-                <a:defRPr b="0" i="0" strike="noStrike" sz="1200" u="none">
-                  <a:solidFill>
-                    <a:srgbClr val="FFFFFF"/>
-                  </a:solidFill>
-                  <a:latin typeface="Arial"/>
-                </a:defRPr>
-              </a:pPr>
-            </a:p>
-          </c:txPr>
           <c:showLegendKey val="0"/>
           <c:showVal val="1"/>
           <c:showCatName val="0"/>
           <c:showSerName val="0"/>
           <c:showPercent val="0"/>
           <c:showBubbleSize val="0"/>
-          <c:showLeaderLines val="0"/>
         </c:dLbls>
         <c:gapWidth val="150"/>
-        <c:overlap val="0"/>
         <c:axId val="2094734554"/>
         <c:axId val="2094734552"/>
-        <c:axId val="2094734556"/>
       </c:barChart>
       <c:catAx>
         <c:axId val="2094734554"/>
@@ -282,13 +287,14 @@
         <c:crosses val="autoZero"/>
         <c:auto val="1"/>
         <c:lblAlgn val="ctr"/>
+        <c:lblOffset val="100"/>
         <c:noMultiLvlLbl val="1"/>
       </c:catAx>
       <c:valAx>
         <c:axId val="2094734552"/>
         <c:scaling>
           <c:orientation val="minMax"/>
-          <c:max val="3"/>
+          <c:max val="4"/>
           <c:min val="0"/>
         </c:scaling>
         <c:delete val="0"/>
@@ -346,6 +352,7 @@
     </c:plotArea>
     <c:plotVisOnly val="1"/>
     <c:dispBlanksAs val="span"/>
+    <c:showDLblsOverMax val="1"/>
   </c:chart>
   <c:spPr>
     <a:noFill/>
@@ -382,234 +389,10 @@
           <a:chExt cx="0" cy="0"/>
         </a:xfrm>
       </p:grpSpPr>
-      <p:sp>
-        <p:nvSpPr>
-          <p:cNvPr id="2" name="Header Placeholder 1"/>
-          <p:cNvSpPr>
-            <a:spLocks noGrp="1"/>
-          </p:cNvSpPr>
-          <p:nvPr>
-            <p:ph type="hdr" sz="quarter"/>
-          </p:nvPr>
-        </p:nvSpPr>
-        <p:spPr>
-          <a:xfrm>
-            <a:off x="0" y="0"/>
-            <a:ext cx="2971800" cy="458788"/>
-          </a:xfrm>
-          <a:prstGeom prst="rect">
-            <a:avLst/>
-          </a:prstGeom>
-        </p:spPr>
-        <p:txBody>
-          <a:bodyPr vert="horz" lIns="91440" tIns="45720" rIns="91440" bIns="45720" rtlCol="0"/>
-          <a:lstStyle>
-            <a:lvl1pPr algn="l">
-              <a:defRPr sz="1200"/>
-            </a:lvl1pPr>
-          </a:lstStyle>
-          <a:p>
-            <a:endParaRPr lang="en-US"/>
-          </a:p>
-        </p:txBody>
-      </p:sp>
-      <p:sp>
-        <p:nvSpPr>
-          <p:cNvPr id="3" name="Date Placeholder 2"/>
-          <p:cNvSpPr>
-            <a:spLocks noGrp="1"/>
-          </p:cNvSpPr>
-          <p:nvPr>
-            <p:ph type="dt" idx="1"/>
-          </p:nvPr>
-        </p:nvSpPr>
-        <p:spPr>
-          <a:xfrm>
-            <a:off x="3884613" y="0"/>
-            <a:ext cx="2971800" cy="458788"/>
-          </a:xfrm>
-          <a:prstGeom prst="rect">
-            <a:avLst/>
-          </a:prstGeom>
-        </p:spPr>
-        <p:txBody>
-          <a:bodyPr vert="horz" lIns="91440" tIns="45720" rIns="91440" bIns="45720" rtlCol="0"/>
-          <a:lstStyle>
-            <a:lvl1pPr algn="r">
-              <a:defRPr sz="1200"/>
-            </a:lvl1pPr>
-          </a:lstStyle>
-          <a:p>
-            <a:fld id="{5282F153-3F37-0F45-9E97-73ACFA13230C}" type="datetimeFigureOut">
-              <a:rPr lang="en-US"/>
-              <a:t>7/23/19</a:t>
-            </a:fld>
-            <a:endParaRPr lang="en-US"/>
-          </a:p>
-        </p:txBody>
-      </p:sp>
-      <p:sp>
-        <p:nvSpPr>
-          <p:cNvPr id="4" name="Slide Image Placeholder 3"/>
-          <p:cNvSpPr>
-            <a:spLocks noGrp="1" noRot="1" noChangeAspect="1"/>
-          </p:cNvSpPr>
-          <p:nvPr>
-            <p:ph type="sldImg" idx="2"/>
-          </p:nvPr>
-        </p:nvSpPr>
-        <p:spPr>
-          <a:xfrm>
-            <a:off x="685800" y="1143000"/>
-            <a:ext cx="5486400" cy="3086100"/>
-          </a:xfrm>
-          <a:prstGeom prst="rect">
-            <a:avLst/>
-          </a:prstGeom>
-          <a:noFill/>
-          <a:ln w="12700">
-            <a:solidFill>
-              <a:prstClr val="black"/>
-            </a:solidFill>
-          </a:ln>
-        </p:spPr>
-        <p:txBody>
-          <a:bodyPr vert="horz" lIns="91440" tIns="45720" rIns="91440" bIns="45720" rtlCol="0" anchor="ctr"/>
-          <a:lstStyle/>
-          <a:p>
-            <a:endParaRPr lang="en-US"/>
-          </a:p>
-        </p:txBody>
-      </p:sp>
-      <p:sp>
-        <p:nvSpPr>
-          <p:cNvPr id="5" name="Notes Placeholder 4"/>
-          <p:cNvSpPr>
-            <a:spLocks noGrp="1"/>
-          </p:cNvSpPr>
-          <p:nvPr>
-            <p:ph type="body" sz="quarter" idx="3"/>
-          </p:nvPr>
-        </p:nvSpPr>
-        <p:spPr>
-          <a:xfrm>
-            <a:off x="685800" y="4400550"/>
-            <a:ext cx="5486400" cy="3600450"/>
-          </a:xfrm>
-          <a:prstGeom prst="rect">
-            <a:avLst/>
-          </a:prstGeom>
-        </p:spPr>
-        <p:txBody>
-          <a:bodyPr vert="horz" lIns="91440" tIns="45720" rIns="91440" bIns="45720" rtlCol="0"/>
-          <a:lstStyle/>
-          <a:p>
-            <a:pPr lvl="0"/>
-            <a:r>
-              <a:rPr lang="en-US"/>
-              <a:t>Click to edit Master text styles</a:t>
-            </a:r>
-          </a:p>
-          <a:p>
-            <a:pPr lvl="1"/>
-            <a:r>
-              <a:rPr lang="en-US"/>
-              <a:t>Second level</a:t>
-            </a:r>
-          </a:p>
-          <a:p>
-            <a:pPr lvl="2"/>
-            <a:r>
-              <a:rPr lang="en-US"/>
-              <a:t>Third level</a:t>
-            </a:r>
-          </a:p>
-          <a:p>
-            <a:pPr lvl="3"/>
-            <a:r>
-              <a:rPr lang="en-US"/>
-              <a:t>Fourth level</a:t>
-            </a:r>
-          </a:p>
-          <a:p>
-            <a:pPr lvl="4"/>
-            <a:r>
-              <a:rPr lang="en-US"/>
-              <a:t>Fifth level</a:t>
-            </a:r>
-          </a:p>
-        </p:txBody>
-      </p:sp>
-      <p:sp>
-        <p:nvSpPr>
-          <p:cNvPr id="6" name="Footer Placeholder 5"/>
-          <p:cNvSpPr>
-            <a:spLocks noGrp="1"/>
-          </p:cNvSpPr>
-          <p:nvPr>
-            <p:ph type="ftr" sz="quarter" idx="4"/>
-          </p:nvPr>
-        </p:nvSpPr>
-        <p:spPr>
-          <a:xfrm>
-            <a:off x="0" y="8685213"/>
-            <a:ext cx="2971800" cy="458787"/>
-          </a:xfrm>
-          <a:prstGeom prst="rect">
-            <a:avLst/>
-          </a:prstGeom>
-        </p:spPr>
-        <p:txBody>
-          <a:bodyPr vert="horz" lIns="91440" tIns="45720" rIns="91440" bIns="45720" rtlCol="0" anchor="b"/>
-          <a:lstStyle>
-            <a:lvl1pPr algn="l">
-              <a:defRPr sz="1200"/>
-            </a:lvl1pPr>
-          </a:lstStyle>
-          <a:p>
-            <a:endParaRPr lang="en-US"/>
-          </a:p>
-        </p:txBody>
-      </p:sp>
-      <p:sp>
-        <p:nvSpPr>
-          <p:cNvPr id="7" name="Slide Number Placeholder 6"/>
-          <p:cNvSpPr>
-            <a:spLocks noGrp="1"/>
-          </p:cNvSpPr>
-          <p:nvPr>
-            <p:ph type="sldNum" sz="quarter" idx="5"/>
-          </p:nvPr>
-        </p:nvSpPr>
-        <p:spPr>
-          <a:xfrm>
-            <a:off x="3884613" y="8685213"/>
-            <a:ext cx="2971800" cy="458787"/>
-          </a:xfrm>
-          <a:prstGeom prst="rect">
-            <a:avLst/>
-          </a:prstGeom>
-        </p:spPr>
-        <p:txBody>
-          <a:bodyPr vert="horz" lIns="91440" tIns="45720" rIns="91440" bIns="45720" rtlCol="0" anchor="b"/>
-          <a:lstStyle>
-            <a:lvl1pPr algn="r">
-              <a:defRPr sz="1200"/>
-            </a:lvl1pPr>
-          </a:lstStyle>
-          <a:p>
-            <a:fld id="{CE5E9CC1-C706-0F49-92D6-E571CC5EEA8F}" type="slidenum">
-              <a:rPr lang="en-US"/>
-              <a:t>‹#›</a:t>
-            </a:fld>
-            <a:endParaRPr lang="en-US"/>
-          </a:p>
-        </p:txBody>
-      </p:sp>
     </p:spTree>
     <p:extLst>
       <p:ext uri="{BB962C8B-B14F-4D97-AF65-F5344CB8AC3E}">
-        <p14:creationId xmlns:p14="http://schemas.microsoft.com/office/powerpoint/2010/main" val="1024086991"/>
+        <p14:creationId xmlns:p14="http://schemas.microsoft.com/office/powerpoint/2010/main" val="3657728060"/>
       </p:ext>
     </p:extLst>
   </p:cSld>
@@ -753,10 +536,6 @@
           <a:bodyPr/>
           <a:lstStyle/>
           <a:p>
-            <a:r>
-              <a:rPr lang="en-US" dirty="0"/>
-              <a:t/>
-            </a:r>
             <a:endParaRPr lang="en-US" dirty="0"/>
           </a:p>
         </p:txBody>
@@ -841,10 +620,6 @@
           <a:bodyPr/>
           <a:lstStyle/>
           <a:p>
-            <a:r>
-              <a:rPr lang="en-US" dirty="0"/>
-              <a:t/>
-            </a:r>
             <a:endParaRPr lang="en-US" dirty="0"/>
           </a:p>
         </p:txBody>
@@ -929,10 +704,6 @@
           <a:bodyPr/>
           <a:lstStyle/>
           <a:p>
-            <a:r>
-              <a:rPr lang="en-US" dirty="0"/>
-              <a:t/>
-            </a:r>
             <a:endParaRPr lang="en-US" dirty="0"/>
           </a:p>
         </p:txBody>
@@ -1017,10 +788,6 @@
           <a:bodyPr/>
           <a:lstStyle/>
           <a:p>
-            <a:r>
-              <a:rPr lang="en-US" dirty="0"/>
-              <a:t/>
-            </a:r>
             <a:endParaRPr lang="en-US" dirty="0"/>
           </a:p>
         </p:txBody>
@@ -1105,10 +872,6 @@
           <a:bodyPr/>
           <a:lstStyle/>
           <a:p>
-            <a:r>
-              <a:rPr lang="en-US" dirty="0"/>
-              <a:t/>
-            </a:r>
             <a:endParaRPr lang="en-US" dirty="0"/>
           </a:p>
         </p:txBody>
@@ -1193,10 +956,6 @@
           <a:bodyPr/>
           <a:lstStyle/>
           <a:p>
-            <a:r>
-              <a:rPr lang="en-US" dirty="0"/>
-              <a:t/>
-            </a:r>
             <a:endParaRPr lang="en-US" dirty="0"/>
           </a:p>
         </p:txBody>
@@ -1270,6 +1029,11 @@
 <file path=ppt/slideMasters/slideMaster1.xml><?xml version="1.0" encoding="utf-8"?>
 <p:sldMaster xmlns:a="http://schemas.openxmlformats.org/drawingml/2006/main" xmlns:r="http://schemas.openxmlformats.org/officeDocument/2006/relationships" xmlns:p="http://schemas.openxmlformats.org/presentationml/2006/main">
   <p:cSld>
+    <p:bg>
+      <p:bgRef idx="1001">
+        <a:schemeClr val="bg1"/>
+      </p:bgRef>
+    </p:bg>
     <p:spTree>
       <p:nvGrpSpPr>
         <p:cNvPr id="1" name=""/>
@@ -1552,6 +1316,7 @@
         <a:solidFill>
           <a:srgbClr val="1E2761"/>
         </a:solidFill>
+        <a:effectLst/>
       </p:bgPr>
     </p:bg>
     <p:spTree>
@@ -1629,11 +1394,11 @@
           <a:bodyPr wrap="square" rtlCol="0" anchor="ctr"/>
           <a:lstStyle/>
           <a:p>
-            <a:pPr indent="0" marL="0">
-              <a:buNone/>
-            </a:pPr>
-            <a:r>
-              <a:rPr lang="en-US" sz="1400" spc="300" kern="0" dirty="0">
+            <a:pPr marL="0" indent="0">
+              <a:buNone/>
+            </a:pPr>
+            <a:r>
+              <a:rPr lang="en-US" sz="1400" kern="0" spc="300" dirty="0">
                 <a:solidFill>
                   <a:srgbClr val="CADCFC"/>
                 </a:solidFill>
@@ -1668,7 +1433,7 @@
           <a:bodyPr wrap="square" rtlCol="0" anchor="ctr"/>
           <a:lstStyle/>
           <a:p>
-            <a:pPr indent="0" marL="0">
+            <a:pPr marL="0" indent="0">
               <a:buNone/>
             </a:pPr>
             <a:r>
@@ -1707,7 +1472,7 @@
           <a:bodyPr wrap="square" rtlCol="0" anchor="ctr"/>
           <a:lstStyle/>
           <a:p>
-            <a:pPr indent="0" marL="0">
+            <a:pPr marL="0" indent="0">
               <a:buNone/>
             </a:pPr>
             <a:r>
@@ -1746,7 +1511,7 @@
           <a:bodyPr wrap="square" rtlCol="0" anchor="ctr"/>
           <a:lstStyle/>
           <a:p>
-            <a:pPr indent="0" marL="0">
+            <a:pPr marL="0" indent="0">
               <a:lnSpc>
                 <a:spcPct val="140000"/>
               </a:lnSpc>
@@ -1761,12 +1526,12 @@
                 <a:ea typeface="Calibri" pitchFamily="34" charset="-122"/>
                 <a:cs typeface="Calibri" pitchFamily="34" charset="-120"/>
               </a:rPr>
-              <a:t>3 active projects reviewed</a:t>
+              <a:t>4 active projects reviewed</a:t>
             </a:r>
             <a:endParaRPr lang="en-US" sz="1200" dirty="0"/>
           </a:p>
           <a:p>
-            <a:pPr indent="0" marL="0">
+            <a:pPr marL="0" indent="0">
               <a:lnSpc>
                 <a:spcPct val="140000"/>
               </a:lnSpc>
@@ -1786,7 +1551,7 @@
             <a:endParaRPr lang="en-US" sz="1200" dirty="0"/>
           </a:p>
           <a:p>
-            <a:pPr indent="0" marL="0">
+            <a:pPr marL="0" indent="0">
               <a:lnSpc>
                 <a:spcPct val="140000"/>
               </a:lnSpc>
@@ -1823,6 +1588,7 @@
         <a:solidFill>
           <a:srgbClr val="FFFFFF"/>
         </a:solidFill>
+        <a:effectLst/>
       </p:bgPr>
     </p:bg>
     <p:spTree>
@@ -1860,7 +1626,7 @@
           <a:bodyPr wrap="square" rtlCol="0" anchor="ctr"/>
           <a:lstStyle/>
           <a:p>
-            <a:pPr indent="0" marL="0">
+            <a:pPr marL="0" indent="0">
               <a:buNone/>
             </a:pPr>
             <a:r>
@@ -1899,7 +1665,7 @@
           <a:bodyPr wrap="square" rtlCol="0" anchor="ctr"/>
           <a:lstStyle/>
           <a:p>
-            <a:pPr indent="0" marL="0">
+            <a:pPr marL="0" indent="0">
               <a:buNone/>
             </a:pPr>
             <a:r>
@@ -1943,7 +1709,7 @@
             <a:prstDash val="solid"/>
           </a:ln>
           <a:effectLst>
-            <a:outerShdw sx="100000" sy="100000" kx="0" ky="0" algn="bl" rotWithShape="0" blurRad="101600" dist="38100" dir="5400000">
+            <a:outerShdw blurRad="101600" dist="38100" dir="5400000" algn="bl" rotWithShape="0">
               <a:srgbClr val="1E2761">
                 <a:alpha val="12000"/>
               </a:srgbClr>
@@ -1972,7 +1738,7 @@
           <a:bodyPr wrap="square" rtlCol="0" anchor="ctr"/>
           <a:lstStyle/>
           <a:p>
-            <a:pPr algn="ctr" indent="0" marL="0">
+            <a:pPr marL="0" indent="0" algn="ctr">
               <a:buNone/>
             </a:pPr>
             <a:r>
@@ -1984,7 +1750,7 @@
                 <a:ea typeface="Cambria" pitchFamily="34" charset="-122"/>
                 <a:cs typeface="Cambria" pitchFamily="34" charset="-120"/>
               </a:rPr>
-              <a:t>2</a:t>
+              <a:t>3</a:t>
             </a:r>
             <a:endParaRPr lang="en-US" sz="4000" dirty="0"/>
           </a:p>
@@ -2011,7 +1777,7 @@
           <a:bodyPr wrap="square" rtlCol="0" anchor="t"/>
           <a:lstStyle/>
           <a:p>
-            <a:pPr algn="ctr" indent="0" marL="0">
+            <a:pPr marL="0" indent="0" algn="ctr">
               <a:buNone/>
             </a:pPr>
             <a:r>
@@ -2055,7 +1821,7 @@
             <a:prstDash val="solid"/>
           </a:ln>
           <a:effectLst>
-            <a:outerShdw sx="100000" sy="100000" kx="0" ky="0" algn="bl" rotWithShape="0" blurRad="101600" dist="38100" dir="5400000">
+            <a:outerShdw blurRad="101600" dist="38100" dir="5400000" algn="bl" rotWithShape="0">
               <a:srgbClr val="1E2761">
                 <a:alpha val="12000"/>
               </a:srgbClr>
@@ -2084,7 +1850,7 @@
           <a:bodyPr wrap="square" rtlCol="0" anchor="ctr"/>
           <a:lstStyle/>
           <a:p>
-            <a:pPr algn="ctr" indent="0" marL="0">
+            <a:pPr marL="0" indent="0" algn="ctr">
               <a:buNone/>
             </a:pPr>
             <a:r>
@@ -2123,7 +1889,7 @@
           <a:bodyPr wrap="square" rtlCol="0" anchor="t"/>
           <a:lstStyle/>
           <a:p>
-            <a:pPr algn="ctr" indent="0" marL="0">
+            <a:pPr marL="0" indent="0" algn="ctr">
               <a:buNone/>
             </a:pPr>
             <a:r>
@@ -2167,7 +1933,7 @@
             <a:prstDash val="solid"/>
           </a:ln>
           <a:effectLst>
-            <a:outerShdw sx="100000" sy="100000" kx="0" ky="0" algn="bl" rotWithShape="0" blurRad="101600" dist="38100" dir="5400000">
+            <a:outerShdw blurRad="101600" dist="38100" dir="5400000" algn="bl" rotWithShape="0">
               <a:srgbClr val="1E2761">
                 <a:alpha val="12000"/>
               </a:srgbClr>
@@ -2196,7 +1962,7 @@
           <a:bodyPr wrap="square" rtlCol="0" anchor="ctr"/>
           <a:lstStyle/>
           <a:p>
-            <a:pPr algn="ctr" indent="0" marL="0">
+            <a:pPr marL="0" indent="0" algn="ctr">
               <a:buNone/>
             </a:pPr>
             <a:r>
@@ -2235,7 +2001,7 @@
           <a:bodyPr wrap="square" rtlCol="0" anchor="t"/>
           <a:lstStyle/>
           <a:p>
-            <a:pPr algn="ctr" indent="0" marL="0">
+            <a:pPr marL="0" indent="0" algn="ctr">
               <a:buNone/>
             </a:pPr>
             <a:r>
@@ -2296,7 +2062,7 @@
           <a:bodyPr wrap="square" rtlCol="0" anchor="t"/>
           <a:lstStyle/>
           <a:p>
-            <a:pPr indent="0" marL="0">
+            <a:pPr marL="0" indent="0">
               <a:lnSpc>
                 <a:spcPct val="130000"/>
               </a:lnSpc>
@@ -2311,12 +2077,12 @@
                 <a:ea typeface="Calibri" pitchFamily="34" charset="-122"/>
                 <a:cs typeface="Calibri" pitchFamily="34" charset="-120"/>
               </a:rPr>
-              <a:t>2 of 3 projects are Red</a:t>
+              <a:t>3 of 4 projects are Red</a:t>
             </a:r>
             <a:endParaRPr lang="en-US" sz="1800" dirty="0"/>
           </a:p>
           <a:p>
-            <a:pPr indent="0" marL="0">
+            <a:pPr marL="0" indent="0">
               <a:lnSpc>
                 <a:spcPct val="130000"/>
               </a:lnSpc>
@@ -2358,7 +2124,7 @@
           <a:bodyPr wrap="square" rtlCol="0" anchor="ctr"/>
           <a:lstStyle/>
           <a:p>
-            <a:pPr indent="0" marL="0">
+            <a:pPr marL="0" indent="0">
               <a:buNone/>
             </a:pPr>
             <a:r>
@@ -2417,7 +2183,7 @@
           <a:bodyPr wrap="square" rtlCol="0" anchor="ctr"/>
           <a:lstStyle/>
           <a:p>
-            <a:pPr indent="0" marL="0">
+            <a:pPr marL="0" indent="0">
               <a:buNone/>
             </a:pPr>
             <a:r>
@@ -2456,7 +2222,7 @@
           <a:bodyPr wrap="square" rtlCol="0" anchor="ctr"/>
           <a:lstStyle/>
           <a:p>
-            <a:pPr indent="0" marL="0">
+            <a:pPr marL="0" indent="0">
               <a:buNone/>
             </a:pPr>
             <a:r>
@@ -2495,7 +2261,7 @@
           <a:bodyPr wrap="square" rtlCol="0" anchor="ctr"/>
           <a:lstStyle/>
           <a:p>
-            <a:pPr algn="r" indent="0" marL="0">
+            <a:pPr marL="0" indent="0" algn="r">
               <a:buNone/>
             </a:pPr>
             <a:r>
@@ -2554,7 +2320,7 @@
           <a:bodyPr wrap="square" rtlCol="0" anchor="ctr"/>
           <a:lstStyle/>
           <a:p>
-            <a:pPr indent="0" marL="0">
+            <a:pPr marL="0" indent="0">
               <a:buNone/>
             </a:pPr>
             <a:r>
@@ -2566,7 +2332,7 @@
                 <a:ea typeface="Calibri" pitchFamily="34" charset="-122"/>
                 <a:cs typeface="Calibri" pitchFamily="34" charset="-120"/>
               </a:rPr>
-              <a:t>Zycus - UniSan S2P Implementation</a:t>
+              <a:t>Zycus - Titan S2P Implementation</a:t>
             </a:r>
             <a:endParaRPr lang="en-US" sz="1200" dirty="0"/>
           </a:p>
@@ -2593,7 +2359,7 @@
           <a:bodyPr wrap="square" rtlCol="0" anchor="ctr"/>
           <a:lstStyle/>
           <a:p>
-            <a:pPr indent="0" marL="0">
+            <a:pPr marL="0" indent="0">
               <a:buNone/>
             </a:pPr>
             <a:r>
@@ -2632,7 +2398,7 @@
           <a:bodyPr wrap="square" rtlCol="0" anchor="ctr"/>
           <a:lstStyle/>
           <a:p>
-            <a:pPr algn="r" indent="0" marL="0">
+            <a:pPr marL="0" indent="0" algn="r">
               <a:buNone/>
             </a:pPr>
             <a:r>
@@ -2644,6 +2410,143 @@
                 <a:ea typeface="Calibri" pitchFamily="34" charset="-122"/>
                 <a:cs typeface="Calibri" pitchFamily="34" charset="-120"/>
               </a:rPr>
+              <a:t>Aftab Hashambhai</a:t>
+            </a:r>
+            <a:endParaRPr lang="en-US" sz="1100" dirty="0"/>
+          </a:p>
+        </p:txBody>
+      </p:sp>
+      <p:sp>
+        <p:nvSpPr>
+          <p:cNvPr id="24" name="Shape 22"/>
+          <p:cNvSpPr/>
+          <p:nvPr/>
+        </p:nvSpPr>
+        <p:spPr>
+          <a:xfrm>
+            <a:off x="594360" y="6318504"/>
+            <a:ext cx="146304" cy="146304"/>
+          </a:xfrm>
+          <a:prstGeom prst="ellipse">
+            <a:avLst/>
+          </a:prstGeom>
+          <a:solidFill>
+            <a:srgbClr val="C0392B"/>
+          </a:solidFill>
+          <a:ln/>
+        </p:spPr>
+      </p:sp>
+      <p:sp>
+        <p:nvSpPr>
+          <p:cNvPr id="25" name="Text 23"/>
+          <p:cNvSpPr/>
+          <p:nvPr/>
+        </p:nvSpPr>
+        <p:spPr>
+          <a:xfrm>
+            <a:off x="822960" y="6245352"/>
+            <a:ext cx="6675120" cy="274320"/>
+          </a:xfrm>
+          <a:prstGeom prst="rect">
+            <a:avLst/>
+          </a:prstGeom>
+          <a:noFill/>
+          <a:ln/>
+        </p:spPr>
+        <p:txBody>
+          <a:bodyPr wrap="square" rtlCol="0" anchor="ctr"/>
+          <a:lstStyle/>
+          <a:p>
+            <a:pPr marL="0" indent="0">
+              <a:buNone/>
+            </a:pPr>
+            <a:r>
+              <a:rPr lang="en-US" sz="1200" dirty="0">
+                <a:solidFill>
+                  <a:srgbClr val="2B2E3A"/>
+                </a:solidFill>
+                <a:latin typeface="Calibri" pitchFamily="34" charset="0"/>
+                <a:ea typeface="Calibri" pitchFamily="34" charset="-122"/>
+                <a:cs typeface="Calibri" pitchFamily="34" charset="-120"/>
+              </a:rPr>
+              <a:t>Zycus - UniSan S2P Implementation</a:t>
+            </a:r>
+            <a:endParaRPr lang="en-US" sz="1200" dirty="0"/>
+          </a:p>
+        </p:txBody>
+      </p:sp>
+      <p:sp>
+        <p:nvSpPr>
+          <p:cNvPr id="26" name="Text 24"/>
+          <p:cNvSpPr/>
+          <p:nvPr/>
+        </p:nvSpPr>
+        <p:spPr>
+          <a:xfrm>
+            <a:off x="7589520" y="6245352"/>
+            <a:ext cx="1188720" cy="274320"/>
+          </a:xfrm>
+          <a:prstGeom prst="rect">
+            <a:avLst/>
+          </a:prstGeom>
+          <a:noFill/>
+          <a:ln/>
+        </p:spPr>
+        <p:txBody>
+          <a:bodyPr wrap="square" rtlCol="0" anchor="ctr"/>
+          <a:lstStyle/>
+          <a:p>
+            <a:pPr marL="0" indent="0">
+              <a:buNone/>
+            </a:pPr>
+            <a:r>
+              <a:rPr lang="en-US" sz="1200" b="1" dirty="0">
+                <a:solidFill>
+                  <a:srgbClr val="C0392B"/>
+                </a:solidFill>
+                <a:latin typeface="Calibri" pitchFamily="34" charset="0"/>
+                <a:ea typeface="Calibri" pitchFamily="34" charset="-122"/>
+                <a:cs typeface="Calibri" pitchFamily="34" charset="-120"/>
+              </a:rPr>
+              <a:t>Red</a:t>
+            </a:r>
+            <a:endParaRPr lang="en-US" sz="1200" dirty="0"/>
+          </a:p>
+        </p:txBody>
+      </p:sp>
+      <p:sp>
+        <p:nvSpPr>
+          <p:cNvPr id="27" name="Text 25"/>
+          <p:cNvSpPr/>
+          <p:nvPr/>
+        </p:nvSpPr>
+        <p:spPr>
+          <a:xfrm>
+            <a:off x="8869680" y="6245352"/>
+            <a:ext cx="2743200" cy="274320"/>
+          </a:xfrm>
+          <a:prstGeom prst="rect">
+            <a:avLst/>
+          </a:prstGeom>
+          <a:noFill/>
+          <a:ln/>
+        </p:spPr>
+        <p:txBody>
+          <a:bodyPr wrap="square" rtlCol="0" anchor="ctr"/>
+          <a:lstStyle/>
+          <a:p>
+            <a:pPr marL="0" indent="0" algn="r">
+              <a:buNone/>
+            </a:pPr>
+            <a:r>
+              <a:rPr lang="en-US" sz="1100" dirty="0">
+                <a:solidFill>
+                  <a:srgbClr val="6B7280"/>
+                </a:solidFill>
+                <a:latin typeface="Calibri" pitchFamily="34" charset="0"/>
+                <a:ea typeface="Calibri" pitchFamily="34" charset="-122"/>
+                <a:cs typeface="Calibri" pitchFamily="34" charset="-120"/>
+              </a:rPr>
               <a:t>Rajat Bothra</a:t>
             </a:r>
             <a:endParaRPr lang="en-US" sz="1100" dirty="0"/>
@@ -2652,13 +2555,13 @@
       </p:sp>
       <p:sp>
         <p:nvSpPr>
-          <p:cNvPr id="24" name="Shape 22"/>
-          <p:cNvSpPr/>
-          <p:nvPr/>
-        </p:nvSpPr>
-        <p:spPr>
-          <a:xfrm>
-            <a:off x="594360" y="6318504"/>
+          <p:cNvPr id="28" name="Shape 26"/>
+          <p:cNvSpPr/>
+          <p:nvPr/>
+        </p:nvSpPr>
+        <p:spPr>
+          <a:xfrm>
+            <a:off x="594360" y="6629400"/>
             <a:ext cx="146304" cy="146304"/>
           </a:xfrm>
           <a:prstGeom prst="ellipse">
@@ -2672,13 +2575,13 @@
       </p:sp>
       <p:sp>
         <p:nvSpPr>
-          <p:cNvPr id="25" name="Text 23"/>
-          <p:cNvSpPr/>
-          <p:nvPr/>
-        </p:nvSpPr>
-        <p:spPr>
-          <a:xfrm>
-            <a:off x="822960" y="6245352"/>
+          <p:cNvPr id="29" name="Text 27"/>
+          <p:cNvSpPr/>
+          <p:nvPr/>
+        </p:nvSpPr>
+        <p:spPr>
+          <a:xfrm>
+            <a:off x="822960" y="6556248"/>
             <a:ext cx="6675120" cy="274320"/>
           </a:xfrm>
           <a:prstGeom prst="rect">
@@ -2691,7 +2594,7 @@
           <a:bodyPr wrap="square" rtlCol="0" anchor="ctr"/>
           <a:lstStyle/>
           <a:p>
-            <a:pPr indent="0" marL="0">
+            <a:pPr marL="0" indent="0">
               <a:buNone/>
             </a:pPr>
             <a:r>
@@ -2711,13 +2614,13 @@
       </p:sp>
       <p:sp>
         <p:nvSpPr>
-          <p:cNvPr id="26" name="Text 24"/>
-          <p:cNvSpPr/>
-          <p:nvPr/>
-        </p:nvSpPr>
-        <p:spPr>
-          <a:xfrm>
-            <a:off x="7589520" y="6245352"/>
+          <p:cNvPr id="30" name="Text 28"/>
+          <p:cNvSpPr/>
+          <p:nvPr/>
+        </p:nvSpPr>
+        <p:spPr>
+          <a:xfrm>
+            <a:off x="7589520" y="6556248"/>
             <a:ext cx="1188720" cy="274320"/>
           </a:xfrm>
           <a:prstGeom prst="rect">
@@ -2730,7 +2633,7 @@
           <a:bodyPr wrap="square" rtlCol="0" anchor="ctr"/>
           <a:lstStyle/>
           <a:p>
-            <a:pPr indent="0" marL="0">
+            <a:pPr marL="0" indent="0">
               <a:buNone/>
             </a:pPr>
             <a:r>
@@ -2750,13 +2653,13 @@
       </p:sp>
       <p:sp>
         <p:nvSpPr>
-          <p:cNvPr id="27" name="Text 25"/>
-          <p:cNvSpPr/>
-          <p:nvPr/>
-        </p:nvSpPr>
-        <p:spPr>
-          <a:xfrm>
-            <a:off x="8869680" y="6245352"/>
+          <p:cNvPr id="31" name="Text 29"/>
+          <p:cNvSpPr/>
+          <p:nvPr/>
+        </p:nvSpPr>
+        <p:spPr>
+          <a:xfrm>
+            <a:off x="8869680" y="6556248"/>
             <a:ext cx="2743200" cy="274320"/>
           </a:xfrm>
           <a:prstGeom prst="rect">
@@ -2769,7 +2672,7 @@
           <a:bodyPr wrap="square" rtlCol="0" anchor="ctr"/>
           <a:lstStyle/>
           <a:p>
-            <a:pPr algn="r" indent="0" marL="0">
+            <a:pPr marL="0" indent="0" algn="r">
               <a:buNone/>
             </a:pPr>
             <a:r>
@@ -2789,13 +2692,13 @@
       </p:sp>
       <p:sp>
         <p:nvSpPr>
-          <p:cNvPr id="28" name="Text 26"/>
-          <p:cNvSpPr/>
-          <p:nvPr/>
-        </p:nvSpPr>
-        <p:spPr>
-          <a:xfrm>
-            <a:off x="457200" y="6473952"/>
+          <p:cNvPr id="32" name="Text 30"/>
+          <p:cNvSpPr/>
+          <p:nvPr/>
+        </p:nvSpPr>
+        <p:spPr>
+          <a:xfrm>
+            <a:off x="457200" y="5024714"/>
             <a:ext cx="7315200" cy="274320"/>
           </a:xfrm>
           <a:prstGeom prst="rect">
@@ -2808,7 +2711,7 @@
           <a:bodyPr wrap="square" rtlCol="0" anchor="ctr"/>
           <a:lstStyle/>
           <a:p>
-            <a:pPr indent="0" marL="0">
+            <a:pPr marL="0" indent="0">
               <a:buNone/>
             </a:pPr>
             <a:r>
@@ -2828,13 +2731,13 @@
       </p:sp>
       <p:sp>
         <p:nvSpPr>
-          <p:cNvPr id="29" name="Text 27"/>
-          <p:cNvSpPr/>
-          <p:nvPr/>
-        </p:nvSpPr>
-        <p:spPr>
-          <a:xfrm>
-            <a:off x="9601200" y="6473952"/>
+          <p:cNvPr id="33" name="Text 31"/>
+          <p:cNvSpPr/>
+          <p:nvPr/>
+        </p:nvSpPr>
+        <p:spPr>
+          <a:xfrm>
+            <a:off x="9509760" y="5212080"/>
             <a:ext cx="2103120" cy="274320"/>
           </a:xfrm>
           <a:prstGeom prst="rect">
@@ -2847,7 +2750,7 @@
           <a:bodyPr wrap="square" rtlCol="0" anchor="ctr"/>
           <a:lstStyle/>
           <a:p>
-            <a:pPr algn="r" indent="0" marL="0">
+            <a:pPr marL="0" indent="0" algn="r">
               <a:buNone/>
             </a:pPr>
             <a:r>
@@ -2881,6 +2784,7 @@
         <a:solidFill>
           <a:srgbClr val="FFFFFF"/>
         </a:solidFill>
+        <a:effectLst/>
       </p:bgPr>
     </p:bg>
     <p:spTree>
@@ -2918,7 +2822,7 @@
           <a:bodyPr wrap="square" rtlCol="0" anchor="ctr"/>
           <a:lstStyle/>
           <a:p>
-            <a:pPr indent="0" marL="0">
+            <a:pPr marL="0" indent="0">
               <a:buNone/>
             </a:pPr>
             <a:r>
@@ -2957,7 +2861,7 @@
           <a:bodyPr wrap="square" rtlCol="0" anchor="ctr"/>
           <a:lstStyle/>
           <a:p>
-            <a:pPr indent="0" marL="0">
+            <a:pPr marL="0" indent="0">
               <a:buNone/>
             </a:pPr>
             <a:r>
@@ -3018,7 +2922,7 @@
           <a:bodyPr wrap="square" rtlCol="0" anchor="ctr"/>
           <a:lstStyle/>
           <a:p>
-            <a:pPr indent="0" marL="0">
+            <a:pPr marL="0" indent="0">
               <a:buNone/>
             </a:pPr>
             <a:r>
@@ -3057,7 +2961,7 @@
           <a:bodyPr wrap="square" rtlCol="0" anchor="ctr"/>
           <a:lstStyle/>
           <a:p>
-            <a:pPr indent="0" marL="0">
+            <a:pPr marL="0" indent="0">
               <a:buNone/>
             </a:pPr>
             <a:r>
@@ -3116,7 +3020,7 @@
           <a:bodyPr wrap="square" rtlCol="0" anchor="ctr"/>
           <a:lstStyle/>
           <a:p>
-            <a:pPr algn="ctr" indent="0" marL="0">
+            <a:pPr marL="0" indent="0" algn="ctr">
               <a:buNone/>
             </a:pPr>
             <a:r>
@@ -3198,7 +3102,7 @@
           <a:bodyPr wrap="square" rtlCol="0" anchor="ctr"/>
           <a:lstStyle/>
           <a:p>
-            <a:pPr algn="ctr" indent="0" marL="0">
+            <a:pPr marL="0" indent="0" algn="ctr">
               <a:buNone/>
             </a:pPr>
             <a:r>
@@ -3280,7 +3184,7 @@
           <a:bodyPr wrap="square" rtlCol="0" anchor="ctr"/>
           <a:lstStyle/>
           <a:p>
-            <a:pPr algn="ctr" indent="0" marL="0">
+            <a:pPr marL="0" indent="0" algn="ctr">
               <a:buNone/>
             </a:pPr>
             <a:r>
@@ -3362,7 +3266,7 @@
           <a:bodyPr wrap="square" rtlCol="0" anchor="ctr"/>
           <a:lstStyle/>
           <a:p>
-            <a:pPr algn="ctr" indent="0" marL="0">
+            <a:pPr marL="0" indent="0" algn="ctr">
               <a:buNone/>
             </a:pPr>
             <a:r>
@@ -3401,7 +3305,7 @@
           <a:bodyPr wrap="square" rtlCol="0" anchor="t"/>
           <a:lstStyle/>
           <a:p>
-            <a:pPr indent="0" marL="0">
+            <a:pPr marL="0" indent="0">
               <a:lnSpc>
                 <a:spcPct val="120000"/>
               </a:lnSpc>
@@ -3465,7 +3369,7 @@
           <a:bodyPr wrap="square" rtlCol="0" anchor="ctr"/>
           <a:lstStyle/>
           <a:p>
-            <a:pPr indent="0" marL="0">
+            <a:pPr marL="0" indent="0">
               <a:buNone/>
             </a:pPr>
             <a:r>
@@ -3477,7 +3381,7 @@
                 <a:ea typeface="Calibri" pitchFamily="34" charset="-122"/>
                 <a:cs typeface="Calibri" pitchFamily="34" charset="-120"/>
               </a:rPr>
-              <a:t>Zycus - UniSan S2P Implementation</a:t>
+              <a:t>Zycus - Titan S2P Implementation</a:t>
             </a:r>
             <a:endParaRPr lang="en-US" sz="1400" dirty="0"/>
           </a:p>
@@ -3504,19 +3408,19 @@
           <a:bodyPr wrap="square" rtlCol="0" anchor="ctr"/>
           <a:lstStyle/>
           <a:p>
-            <a:pPr indent="0" marL="0">
+            <a:pPr marL="0" indent="0">
               <a:buNone/>
             </a:pPr>
             <a:r>
               <a:rPr lang="en-US" sz="1200" b="1" dirty="0">
                 <a:solidFill>
-                  <a:srgbClr val="C0392B"/>
-                </a:solidFill>
-                <a:latin typeface="Calibri" pitchFamily="34" charset="0"/>
-                <a:ea typeface="Calibri" pitchFamily="34" charset="-122"/>
-                <a:cs typeface="Calibri" pitchFamily="34" charset="-120"/>
-              </a:rPr>
-              <a:t>Worsening</a:t>
+                  <a:srgbClr val="6B7280"/>
+                </a:solidFill>
+                <a:latin typeface="Calibri" pitchFamily="34" charset="0"/>
+                <a:ea typeface="Calibri" pitchFamily="34" charset="-122"/>
+                <a:cs typeface="Calibri" pitchFamily="34" charset="-120"/>
+              </a:rPr>
+              <a:t>Steady</a:t>
             </a:r>
             <a:endParaRPr lang="en-US" sz="1200" dirty="0"/>
           </a:p>
@@ -3537,7 +3441,7 @@
             <a:avLst/>
           </a:prstGeom>
           <a:solidFill>
-            <a:srgbClr val="D9A441"/>
+            <a:srgbClr val="C0392B"/>
           </a:solidFill>
           <a:ln/>
         </p:spPr>
@@ -3563,7 +3467,7 @@
           <a:bodyPr wrap="square" rtlCol="0" anchor="ctr"/>
           <a:lstStyle/>
           <a:p>
-            <a:pPr algn="ctr" indent="0" marL="0">
+            <a:pPr marL="0" indent="0" algn="ctr">
               <a:buNone/>
             </a:pPr>
             <a:r>
@@ -3619,7 +3523,7 @@
             <a:avLst/>
           </a:prstGeom>
           <a:solidFill>
-            <a:srgbClr val="D9A441"/>
+            <a:srgbClr val="C0392B"/>
           </a:solidFill>
           <a:ln/>
         </p:spPr>
@@ -3645,7 +3549,7 @@
           <a:bodyPr wrap="square" rtlCol="0" anchor="ctr"/>
           <a:lstStyle/>
           <a:p>
-            <a:pPr algn="ctr" indent="0" marL="0">
+            <a:pPr marL="0" indent="0" algn="ctr">
               <a:buNone/>
             </a:pPr>
             <a:r>
@@ -3727,7 +3631,7 @@
           <a:bodyPr wrap="square" rtlCol="0" anchor="ctr"/>
           <a:lstStyle/>
           <a:p>
-            <a:pPr algn="ctr" indent="0" marL="0">
+            <a:pPr marL="0" indent="0" algn="ctr">
               <a:buNone/>
             </a:pPr>
             <a:r>
@@ -3747,13 +3651,214 @@
       </p:sp>
       <p:sp>
         <p:nvSpPr>
-          <p:cNvPr id="30" name="Shape 28"/>
-          <p:cNvSpPr/>
-          <p:nvPr/>
-        </p:nvSpPr>
-        <p:spPr>
-          <a:xfrm>
-            <a:off x="5285232" y="3657600"/>
+          <p:cNvPr id="30" name="Text 28"/>
+          <p:cNvSpPr/>
+          <p:nvPr/>
+        </p:nvSpPr>
+        <p:spPr>
+          <a:xfrm>
+            <a:off x="5852160" y="3127248"/>
+            <a:ext cx="5577840" cy="1005840"/>
+          </a:xfrm>
+          <a:prstGeom prst="rect">
+            <a:avLst/>
+          </a:prstGeom>
+          <a:noFill/>
+          <a:ln/>
+        </p:spPr>
+        <p:txBody>
+          <a:bodyPr wrap="square" rtlCol="0" anchor="t"/>
+          <a:lstStyle/>
+          <a:p>
+            <a:pPr marL="0" indent="0">
+              <a:lnSpc>
+                <a:spcPct val="120000"/>
+              </a:lnSpc>
+              <a:buNone/>
+            </a:pPr>
+            <a:r>
+              <a:rPr lang="en-US" sz="1100" dirty="0">
+                <a:solidFill>
+                  <a:srgbClr val="2B2E3A"/>
+                </a:solidFill>
+                <a:latin typeface="Calibri" pitchFamily="34" charset="0"/>
+                <a:ea typeface="Calibri" pitchFamily="34" charset="-122"/>
+                <a:cs typeface="Calibri" pitchFamily="34" charset="-120"/>
+              </a:rPr>
+              <a:t>Zycus - Titan S2P Implementation is off track and needs immediate leadership intervention.</a:t>
+            </a:r>
+            <a:endParaRPr lang="en-US" sz="1100" dirty="0"/>
+          </a:p>
+        </p:txBody>
+      </p:sp>
+      <p:sp>
+        <p:nvSpPr>
+          <p:cNvPr id="31" name="Shape 29"/>
+          <p:cNvSpPr/>
+          <p:nvPr/>
+        </p:nvSpPr>
+        <p:spPr>
+          <a:xfrm>
+            <a:off x="548640" y="4434840"/>
+            <a:ext cx="11064240" cy="1234440"/>
+          </a:xfrm>
+          <a:prstGeom prst="roundRect">
+            <a:avLst>
+              <a:gd name="adj" fmla="val 5926"/>
+            </a:avLst>
+          </a:prstGeom>
+          <a:solidFill>
+            <a:srgbClr val="F9FAFB"/>
+          </a:solidFill>
+          <a:ln/>
+        </p:spPr>
+      </p:sp>
+      <p:sp>
+        <p:nvSpPr>
+          <p:cNvPr id="32" name="Text 30"/>
+          <p:cNvSpPr/>
+          <p:nvPr/>
+        </p:nvSpPr>
+        <p:spPr>
+          <a:xfrm>
+            <a:off x="777240" y="4544568"/>
+            <a:ext cx="4754880" cy="365760"/>
+          </a:xfrm>
+          <a:prstGeom prst="rect">
+            <a:avLst/>
+          </a:prstGeom>
+          <a:noFill/>
+          <a:ln/>
+        </p:spPr>
+        <p:txBody>
+          <a:bodyPr wrap="square" rtlCol="0" anchor="ctr"/>
+          <a:lstStyle/>
+          <a:p>
+            <a:pPr marL="0" indent="0">
+              <a:buNone/>
+            </a:pPr>
+            <a:r>
+              <a:rPr lang="en-US" sz="1400" b="1" dirty="0">
+                <a:solidFill>
+                  <a:srgbClr val="2B2E3A"/>
+                </a:solidFill>
+                <a:latin typeface="Calibri" pitchFamily="34" charset="0"/>
+                <a:ea typeface="Calibri" pitchFamily="34" charset="-122"/>
+                <a:cs typeface="Calibri" pitchFamily="34" charset="-120"/>
+              </a:rPr>
+              <a:t>Zycus - UniSan S2P Implementation</a:t>
+            </a:r>
+            <a:endParaRPr lang="en-US" sz="1400" dirty="0"/>
+          </a:p>
+        </p:txBody>
+      </p:sp>
+      <p:sp>
+        <p:nvSpPr>
+          <p:cNvPr id="33" name="Text 31"/>
+          <p:cNvSpPr/>
+          <p:nvPr/>
+        </p:nvSpPr>
+        <p:spPr>
+          <a:xfrm>
+            <a:off x="777240" y="4937760"/>
+            <a:ext cx="2011680" cy="320040"/>
+          </a:xfrm>
+          <a:prstGeom prst="rect">
+            <a:avLst/>
+          </a:prstGeom>
+          <a:noFill/>
+          <a:ln/>
+        </p:spPr>
+        <p:txBody>
+          <a:bodyPr wrap="square" rtlCol="0" anchor="ctr"/>
+          <a:lstStyle/>
+          <a:p>
+            <a:pPr marL="0" indent="0">
+              <a:buNone/>
+            </a:pPr>
+            <a:r>
+              <a:rPr lang="en-US" sz="1200" b="1" dirty="0">
+                <a:solidFill>
+                  <a:srgbClr val="C0392B"/>
+                </a:solidFill>
+                <a:latin typeface="Calibri" pitchFamily="34" charset="0"/>
+                <a:ea typeface="Calibri" pitchFamily="34" charset="-122"/>
+                <a:cs typeface="Calibri" pitchFamily="34" charset="-120"/>
+              </a:rPr>
+              <a:t>Worsening</a:t>
+            </a:r>
+            <a:endParaRPr lang="en-US" sz="1200" dirty="0"/>
+          </a:p>
+        </p:txBody>
+      </p:sp>
+      <p:sp>
+        <p:nvSpPr>
+          <p:cNvPr id="34" name="Shape 32"/>
+          <p:cNvSpPr/>
+          <p:nvPr/>
+        </p:nvSpPr>
+        <p:spPr>
+          <a:xfrm>
+            <a:off x="3017520" y="5001768"/>
+            <a:ext cx="146304" cy="146304"/>
+          </a:xfrm>
+          <a:prstGeom prst="ellipse">
+            <a:avLst/>
+          </a:prstGeom>
+          <a:solidFill>
+            <a:srgbClr val="D9A441"/>
+          </a:solidFill>
+          <a:ln/>
+        </p:spPr>
+      </p:sp>
+      <p:sp>
+        <p:nvSpPr>
+          <p:cNvPr id="35" name="Text 33"/>
+          <p:cNvSpPr/>
+          <p:nvPr/>
+        </p:nvSpPr>
+        <p:spPr>
+          <a:xfrm>
+            <a:off x="2788920" y="5212080"/>
+            <a:ext cx="640080" cy="228600"/>
+          </a:xfrm>
+          <a:prstGeom prst="rect">
+            <a:avLst/>
+          </a:prstGeom>
+          <a:noFill/>
+          <a:ln/>
+        </p:spPr>
+        <p:txBody>
+          <a:bodyPr wrap="square" rtlCol="0" anchor="ctr"/>
+          <a:lstStyle/>
+          <a:p>
+            <a:pPr marL="0" indent="0" algn="ctr">
+              <a:buNone/>
+            </a:pPr>
+            <a:r>
+              <a:rPr lang="en-US" sz="800" dirty="0">
+                <a:solidFill>
+                  <a:srgbClr val="6B7280"/>
+                </a:solidFill>
+                <a:latin typeface="Calibri" pitchFamily="34" charset="0"/>
+                <a:ea typeface="Calibri" pitchFamily="34" charset="-122"/>
+                <a:cs typeface="Calibri" pitchFamily="34" charset="-120"/>
+              </a:rPr>
+              <a:t>06-18</a:t>
+            </a:r>
+            <a:endParaRPr lang="en-US" sz="800" dirty="0"/>
+          </a:p>
+        </p:txBody>
+      </p:sp>
+      <p:sp>
+        <p:nvSpPr>
+          <p:cNvPr id="36" name="Shape 34"/>
+          <p:cNvSpPr/>
+          <p:nvPr/>
+        </p:nvSpPr>
+        <p:spPr>
+          <a:xfrm>
+            <a:off x="3163824" y="5074920"/>
             <a:ext cx="914400" cy="0"/>
           </a:xfrm>
           <a:prstGeom prst="line">
@@ -3770,33 +3875,33 @@
       </p:sp>
       <p:sp>
         <p:nvSpPr>
-          <p:cNvPr id="31" name="Shape 29"/>
-          <p:cNvSpPr/>
-          <p:nvPr/>
-        </p:nvSpPr>
-        <p:spPr>
-          <a:xfrm>
-            <a:off x="6199632" y="3584448"/>
+          <p:cNvPr id="37" name="Shape 35"/>
+          <p:cNvSpPr/>
+          <p:nvPr/>
+        </p:nvSpPr>
+        <p:spPr>
+          <a:xfrm>
+            <a:off x="4078224" y="5001768"/>
             <a:ext cx="146304" cy="146304"/>
           </a:xfrm>
           <a:prstGeom prst="ellipse">
             <a:avLst/>
           </a:prstGeom>
           <a:solidFill>
-            <a:srgbClr val="C0392B"/>
+            <a:srgbClr val="D9A441"/>
           </a:solidFill>
           <a:ln/>
         </p:spPr>
       </p:sp>
       <p:sp>
         <p:nvSpPr>
-          <p:cNvPr id="32" name="Text 30"/>
-          <p:cNvSpPr/>
-          <p:nvPr/>
-        </p:nvSpPr>
-        <p:spPr>
-          <a:xfrm>
-            <a:off x="5971032" y="3794760"/>
+          <p:cNvPr id="38" name="Text 36"/>
+          <p:cNvSpPr/>
+          <p:nvPr/>
+        </p:nvSpPr>
+        <p:spPr>
+          <a:xfrm>
+            <a:off x="3849624" y="5212080"/>
             <a:ext cx="640080" cy="228600"/>
           </a:xfrm>
           <a:prstGeom prst="rect">
@@ -3809,7 +3914,7 @@
           <a:bodyPr wrap="square" rtlCol="0" anchor="ctr"/>
           <a:lstStyle/>
           <a:p>
-            <a:pPr algn="ctr" indent="0" marL="0">
+            <a:pPr marL="0" indent="0" algn="ctr">
               <a:buNone/>
             </a:pPr>
             <a:r>
@@ -3821,7 +3926,7 @@
                 <a:ea typeface="Calibri" pitchFamily="34" charset="-122"/>
                 <a:cs typeface="Calibri" pitchFamily="34" charset="-120"/>
               </a:rPr>
-              <a:t>07-09</a:t>
+              <a:t>06-25</a:t>
             </a:r>
             <a:endParaRPr lang="en-US" sz="800" dirty="0"/>
           </a:p>
@@ -3829,214 +3934,13 @@
       </p:sp>
       <p:sp>
         <p:nvSpPr>
-          <p:cNvPr id="33" name="Text 31"/>
-          <p:cNvSpPr/>
-          <p:nvPr/>
-        </p:nvSpPr>
-        <p:spPr>
-          <a:xfrm>
-            <a:off x="5852160" y="3127248"/>
-            <a:ext cx="5577840" cy="1005840"/>
-          </a:xfrm>
-          <a:prstGeom prst="rect">
-            <a:avLst/>
-          </a:prstGeom>
-          <a:noFill/>
-          <a:ln/>
-        </p:spPr>
-        <p:txBody>
-          <a:bodyPr wrap="square" rtlCol="0" anchor="t"/>
-          <a:lstStyle/>
-          <a:p>
-            <a:pPr indent="0" marL="0">
-              <a:lnSpc>
-                <a:spcPct val="120000"/>
-              </a:lnSpc>
-              <a:buNone/>
-            </a:pPr>
-            <a:r>
-              <a:rPr lang="en-US" sz="1100" dirty="0">
-                <a:solidFill>
-                  <a:srgbClr val="2B2E3A"/>
-                </a:solidFill>
-                <a:latin typeface="Calibri" pitchFamily="34" charset="0"/>
-                <a:ea typeface="Calibri" pitchFamily="34" charset="-122"/>
-                <a:cs typeface="Calibri" pitchFamily="34" charset="-120"/>
-              </a:rPr>
-              <a:t>Zycus - UniSan S2P Implementation is off track and needs immediate leadership intervention.</a:t>
-            </a:r>
-            <a:endParaRPr lang="en-US" sz="1100" dirty="0"/>
-          </a:p>
-        </p:txBody>
-      </p:sp>
-      <p:sp>
-        <p:nvSpPr>
-          <p:cNvPr id="34" name="Shape 32"/>
-          <p:cNvSpPr/>
-          <p:nvPr/>
-        </p:nvSpPr>
-        <p:spPr>
-          <a:xfrm>
-            <a:off x="548640" y="4434840"/>
-            <a:ext cx="11064240" cy="1234440"/>
-          </a:xfrm>
-          <a:prstGeom prst="roundRect">
-            <a:avLst>
-              <a:gd name="adj" fmla="val 5926"/>
-            </a:avLst>
-          </a:prstGeom>
-          <a:solidFill>
-            <a:srgbClr val="F9FAFB"/>
-          </a:solidFill>
-          <a:ln/>
-        </p:spPr>
-      </p:sp>
-      <p:sp>
-        <p:nvSpPr>
-          <p:cNvPr id="35" name="Text 33"/>
-          <p:cNvSpPr/>
-          <p:nvPr/>
-        </p:nvSpPr>
-        <p:spPr>
-          <a:xfrm>
-            <a:off x="777240" y="4544568"/>
-            <a:ext cx="4754880" cy="365760"/>
-          </a:xfrm>
-          <a:prstGeom prst="rect">
-            <a:avLst/>
-          </a:prstGeom>
-          <a:noFill/>
-          <a:ln/>
-        </p:spPr>
-        <p:txBody>
-          <a:bodyPr wrap="square" rtlCol="0" anchor="ctr"/>
-          <a:lstStyle/>
-          <a:p>
-            <a:pPr indent="0" marL="0">
-              <a:buNone/>
-            </a:pPr>
-            <a:r>
-              <a:rPr lang="en-US" sz="1400" b="1" dirty="0">
-                <a:solidFill>
-                  <a:srgbClr val="2B2E3A"/>
-                </a:solidFill>
-                <a:latin typeface="Calibri" pitchFamily="34" charset="0"/>
-                <a:ea typeface="Calibri" pitchFamily="34" charset="-122"/>
-                <a:cs typeface="Calibri" pitchFamily="34" charset="-120"/>
-              </a:rPr>
-              <a:t>Meridian HR Suite Rollout - Northwind Retail</a:t>
-            </a:r>
-            <a:endParaRPr lang="en-US" sz="1400" dirty="0"/>
-          </a:p>
-        </p:txBody>
-      </p:sp>
-      <p:sp>
-        <p:nvSpPr>
-          <p:cNvPr id="36" name="Text 34"/>
-          <p:cNvSpPr/>
-          <p:nvPr/>
-        </p:nvSpPr>
-        <p:spPr>
-          <a:xfrm>
-            <a:off x="777240" y="4937760"/>
-            <a:ext cx="2011680" cy="320040"/>
-          </a:xfrm>
-          <a:prstGeom prst="rect">
-            <a:avLst/>
-          </a:prstGeom>
-          <a:noFill/>
-          <a:ln/>
-        </p:spPr>
-        <p:txBody>
-          <a:bodyPr wrap="square" rtlCol="0" anchor="ctr"/>
-          <a:lstStyle/>
-          <a:p>
-            <a:pPr indent="0" marL="0">
-              <a:buNone/>
-            </a:pPr>
-            <a:r>
-              <a:rPr lang="en-US" sz="1200" b="1" dirty="0">
-                <a:solidFill>
-                  <a:srgbClr val="6B7280"/>
-                </a:solidFill>
-                <a:latin typeface="Calibri" pitchFamily="34" charset="0"/>
-                <a:ea typeface="Calibri" pitchFamily="34" charset="-122"/>
-                <a:cs typeface="Calibri" pitchFamily="34" charset="-120"/>
-              </a:rPr>
-              <a:t>Steady</a:t>
-            </a:r>
-            <a:endParaRPr lang="en-US" sz="1200" dirty="0"/>
-          </a:p>
-        </p:txBody>
-      </p:sp>
-      <p:sp>
-        <p:nvSpPr>
-          <p:cNvPr id="37" name="Shape 35"/>
-          <p:cNvSpPr/>
-          <p:nvPr/>
-        </p:nvSpPr>
-        <p:spPr>
-          <a:xfrm>
-            <a:off x="3017520" y="5001768"/>
-            <a:ext cx="146304" cy="146304"/>
-          </a:xfrm>
-          <a:prstGeom prst="ellipse">
-            <a:avLst/>
-          </a:prstGeom>
-          <a:solidFill>
-            <a:srgbClr val="2E8B57"/>
-          </a:solidFill>
-          <a:ln/>
-        </p:spPr>
-      </p:sp>
-      <p:sp>
-        <p:nvSpPr>
-          <p:cNvPr id="38" name="Text 36"/>
-          <p:cNvSpPr/>
-          <p:nvPr/>
-        </p:nvSpPr>
-        <p:spPr>
-          <a:xfrm>
-            <a:off x="2788920" y="5212080"/>
-            <a:ext cx="640080" cy="228600"/>
-          </a:xfrm>
-          <a:prstGeom prst="rect">
-            <a:avLst/>
-          </a:prstGeom>
-          <a:noFill/>
-          <a:ln/>
-        </p:spPr>
-        <p:txBody>
-          <a:bodyPr wrap="square" rtlCol="0" anchor="ctr"/>
-          <a:lstStyle/>
-          <a:p>
-            <a:pPr algn="ctr" indent="0" marL="0">
-              <a:buNone/>
-            </a:pPr>
-            <a:r>
-              <a:rPr lang="en-US" sz="800" dirty="0">
-                <a:solidFill>
-                  <a:srgbClr val="6B7280"/>
-                </a:solidFill>
-                <a:latin typeface="Calibri" pitchFamily="34" charset="0"/>
-                <a:ea typeface="Calibri" pitchFamily="34" charset="-122"/>
-                <a:cs typeface="Calibri" pitchFamily="34" charset="-120"/>
-              </a:rPr>
-              <a:t>06-18</a:t>
-            </a:r>
-            <a:endParaRPr lang="en-US" sz="800" dirty="0"/>
-          </a:p>
-        </p:txBody>
-      </p:sp>
-      <p:sp>
-        <p:nvSpPr>
           <p:cNvPr id="39" name="Shape 37"/>
           <p:cNvSpPr/>
           <p:nvPr/>
         </p:nvSpPr>
         <p:spPr>
           <a:xfrm>
-            <a:off x="3163824" y="5074920"/>
+            <a:off x="4224528" y="5074920"/>
             <a:ext cx="914400" cy="0"/>
           </a:xfrm>
           <a:prstGeom prst="line">
@@ -4059,14 +3963,14 @@
         </p:nvSpPr>
         <p:spPr>
           <a:xfrm>
-            <a:off x="4078224" y="5001768"/>
+            <a:off x="5138928" y="5001768"/>
             <a:ext cx="146304" cy="146304"/>
           </a:xfrm>
           <a:prstGeom prst="ellipse">
             <a:avLst/>
           </a:prstGeom>
           <a:solidFill>
-            <a:srgbClr val="2E8B57"/>
+            <a:srgbClr val="C0392B"/>
           </a:solidFill>
           <a:ln/>
         </p:spPr>
@@ -4079,7 +3983,7 @@
         </p:nvSpPr>
         <p:spPr>
           <a:xfrm>
-            <a:off x="3849624" y="5212080"/>
+            <a:off x="4910328" y="5212080"/>
             <a:ext cx="640080" cy="228600"/>
           </a:xfrm>
           <a:prstGeom prst="rect">
@@ -4092,7 +3996,7 @@
           <a:bodyPr wrap="square" rtlCol="0" anchor="ctr"/>
           <a:lstStyle/>
           <a:p>
-            <a:pPr algn="ctr" indent="0" marL="0">
+            <a:pPr marL="0" indent="0" algn="ctr">
               <a:buNone/>
             </a:pPr>
             <a:r>
@@ -4104,7 +4008,7 @@
                 <a:ea typeface="Calibri" pitchFamily="34" charset="-122"/>
                 <a:cs typeface="Calibri" pitchFamily="34" charset="-120"/>
               </a:rPr>
-              <a:t>06-25</a:t>
+              <a:t>07-02</a:t>
             </a:r>
             <a:endParaRPr lang="en-US" sz="800" dirty="0"/>
           </a:p>
@@ -4118,7 +4022,7 @@
         </p:nvSpPr>
         <p:spPr>
           <a:xfrm>
-            <a:off x="4224528" y="5074920"/>
+            <a:off x="5285232" y="5074920"/>
             <a:ext cx="914400" cy="0"/>
           </a:xfrm>
           <a:prstGeom prst="line">
@@ -4141,7 +4045,208 @@
         </p:nvSpPr>
         <p:spPr>
           <a:xfrm>
-            <a:off x="5138928" y="5001768"/>
+            <a:off x="6199632" y="5001768"/>
+            <a:ext cx="146304" cy="146304"/>
+          </a:xfrm>
+          <a:prstGeom prst="ellipse">
+            <a:avLst/>
+          </a:prstGeom>
+          <a:solidFill>
+            <a:srgbClr val="C0392B"/>
+          </a:solidFill>
+          <a:ln/>
+        </p:spPr>
+      </p:sp>
+      <p:sp>
+        <p:nvSpPr>
+          <p:cNvPr id="44" name="Text 42"/>
+          <p:cNvSpPr/>
+          <p:nvPr/>
+        </p:nvSpPr>
+        <p:spPr>
+          <a:xfrm>
+            <a:off x="5971032" y="5212080"/>
+            <a:ext cx="640080" cy="228600"/>
+          </a:xfrm>
+          <a:prstGeom prst="rect">
+            <a:avLst/>
+          </a:prstGeom>
+          <a:noFill/>
+          <a:ln/>
+        </p:spPr>
+        <p:txBody>
+          <a:bodyPr wrap="square" rtlCol="0" anchor="ctr"/>
+          <a:lstStyle/>
+          <a:p>
+            <a:pPr marL="0" indent="0" algn="ctr">
+              <a:buNone/>
+            </a:pPr>
+            <a:r>
+              <a:rPr lang="en-US" sz="800" dirty="0">
+                <a:solidFill>
+                  <a:srgbClr val="6B7280"/>
+                </a:solidFill>
+                <a:latin typeface="Calibri" pitchFamily="34" charset="0"/>
+                <a:ea typeface="Calibri" pitchFamily="34" charset="-122"/>
+                <a:cs typeface="Calibri" pitchFamily="34" charset="-120"/>
+              </a:rPr>
+              <a:t>07-09</a:t>
+            </a:r>
+            <a:endParaRPr lang="en-US" sz="800" dirty="0"/>
+          </a:p>
+        </p:txBody>
+      </p:sp>
+      <p:sp>
+        <p:nvSpPr>
+          <p:cNvPr id="45" name="Text 43"/>
+          <p:cNvSpPr/>
+          <p:nvPr/>
+        </p:nvSpPr>
+        <p:spPr>
+          <a:xfrm>
+            <a:off x="5852160" y="4544568"/>
+            <a:ext cx="5577840" cy="1005840"/>
+          </a:xfrm>
+          <a:prstGeom prst="rect">
+            <a:avLst/>
+          </a:prstGeom>
+          <a:noFill/>
+          <a:ln/>
+        </p:spPr>
+        <p:txBody>
+          <a:bodyPr wrap="square" rtlCol="0" anchor="t"/>
+          <a:lstStyle/>
+          <a:p>
+            <a:pPr marL="0" indent="0">
+              <a:lnSpc>
+                <a:spcPct val="120000"/>
+              </a:lnSpc>
+              <a:buNone/>
+            </a:pPr>
+            <a:r>
+              <a:rPr lang="en-US" sz="1100" dirty="0">
+                <a:solidFill>
+                  <a:srgbClr val="2B2E3A"/>
+                </a:solidFill>
+                <a:latin typeface="Calibri" pitchFamily="34" charset="0"/>
+                <a:ea typeface="Calibri" pitchFamily="34" charset="-122"/>
+                <a:cs typeface="Calibri" pitchFamily="34" charset="-120"/>
+              </a:rPr>
+              <a:t>Zycus - UniSan S2P Implementation is off track and needs immediate leadership intervention.</a:t>
+            </a:r>
+            <a:endParaRPr lang="en-US" sz="1100" dirty="0"/>
+          </a:p>
+        </p:txBody>
+      </p:sp>
+      <p:sp>
+        <p:nvSpPr>
+          <p:cNvPr id="46" name="Shape 44"/>
+          <p:cNvSpPr/>
+          <p:nvPr/>
+        </p:nvSpPr>
+        <p:spPr>
+          <a:xfrm>
+            <a:off x="548640" y="5852160"/>
+            <a:ext cx="11064240" cy="1234440"/>
+          </a:xfrm>
+          <a:prstGeom prst="roundRect">
+            <a:avLst>
+              <a:gd name="adj" fmla="val 5926"/>
+            </a:avLst>
+          </a:prstGeom>
+          <a:solidFill>
+            <a:srgbClr val="F9FAFB"/>
+          </a:solidFill>
+          <a:ln/>
+        </p:spPr>
+      </p:sp>
+      <p:sp>
+        <p:nvSpPr>
+          <p:cNvPr id="47" name="Text 45"/>
+          <p:cNvSpPr/>
+          <p:nvPr/>
+        </p:nvSpPr>
+        <p:spPr>
+          <a:xfrm>
+            <a:off x="777240" y="5961888"/>
+            <a:ext cx="4754880" cy="365760"/>
+          </a:xfrm>
+          <a:prstGeom prst="rect">
+            <a:avLst/>
+          </a:prstGeom>
+          <a:noFill/>
+          <a:ln/>
+        </p:spPr>
+        <p:txBody>
+          <a:bodyPr wrap="square" rtlCol="0" anchor="ctr"/>
+          <a:lstStyle/>
+          <a:p>
+            <a:pPr marL="0" indent="0">
+              <a:buNone/>
+            </a:pPr>
+            <a:r>
+              <a:rPr lang="en-US" sz="1400" b="1" dirty="0">
+                <a:solidFill>
+                  <a:srgbClr val="2B2E3A"/>
+                </a:solidFill>
+                <a:latin typeface="Calibri" pitchFamily="34" charset="0"/>
+                <a:ea typeface="Calibri" pitchFamily="34" charset="-122"/>
+                <a:cs typeface="Calibri" pitchFamily="34" charset="-120"/>
+              </a:rPr>
+              <a:t>Meridian HR Suite Rollout - Northwind Retail</a:t>
+            </a:r>
+            <a:endParaRPr lang="en-US" sz="1400" dirty="0"/>
+          </a:p>
+        </p:txBody>
+      </p:sp>
+      <p:sp>
+        <p:nvSpPr>
+          <p:cNvPr id="48" name="Text 46"/>
+          <p:cNvSpPr/>
+          <p:nvPr/>
+        </p:nvSpPr>
+        <p:spPr>
+          <a:xfrm>
+            <a:off x="777240" y="6355080"/>
+            <a:ext cx="2011680" cy="320040"/>
+          </a:xfrm>
+          <a:prstGeom prst="rect">
+            <a:avLst/>
+          </a:prstGeom>
+          <a:noFill/>
+          <a:ln/>
+        </p:spPr>
+        <p:txBody>
+          <a:bodyPr wrap="square" rtlCol="0" anchor="ctr"/>
+          <a:lstStyle/>
+          <a:p>
+            <a:pPr marL="0" indent="0">
+              <a:buNone/>
+            </a:pPr>
+            <a:r>
+              <a:rPr lang="en-US" sz="1200" b="1" dirty="0">
+                <a:solidFill>
+                  <a:srgbClr val="6B7280"/>
+                </a:solidFill>
+                <a:latin typeface="Calibri" pitchFamily="34" charset="0"/>
+                <a:ea typeface="Calibri" pitchFamily="34" charset="-122"/>
+                <a:cs typeface="Calibri" pitchFamily="34" charset="-120"/>
+              </a:rPr>
+              <a:t>Steady</a:t>
+            </a:r>
+            <a:endParaRPr lang="en-US" sz="1200" dirty="0"/>
+          </a:p>
+        </p:txBody>
+      </p:sp>
+      <p:sp>
+        <p:nvSpPr>
+          <p:cNvPr id="49" name="Shape 47"/>
+          <p:cNvSpPr/>
+          <p:nvPr/>
+        </p:nvSpPr>
+        <p:spPr>
+          <a:xfrm>
+            <a:off x="3017520" y="6419088"/>
             <a:ext cx="146304" cy="146304"/>
           </a:xfrm>
           <a:prstGeom prst="ellipse">
@@ -4155,13 +4260,13 @@
       </p:sp>
       <p:sp>
         <p:nvSpPr>
-          <p:cNvPr id="44" name="Text 42"/>
-          <p:cNvSpPr/>
-          <p:nvPr/>
-        </p:nvSpPr>
-        <p:spPr>
-          <a:xfrm>
-            <a:off x="4910328" y="5212080"/>
+          <p:cNvPr id="50" name="Text 48"/>
+          <p:cNvSpPr/>
+          <p:nvPr/>
+        </p:nvSpPr>
+        <p:spPr>
+          <a:xfrm>
+            <a:off x="2788920" y="6629400"/>
             <a:ext cx="640080" cy="228600"/>
           </a:xfrm>
           <a:prstGeom prst="rect">
@@ -4174,7 +4279,7 @@
           <a:bodyPr wrap="square" rtlCol="0" anchor="ctr"/>
           <a:lstStyle/>
           <a:p>
-            <a:pPr algn="ctr" indent="0" marL="0">
+            <a:pPr marL="0" indent="0" algn="ctr">
               <a:buNone/>
             </a:pPr>
             <a:r>
@@ -4186,7 +4291,7 @@
                 <a:ea typeface="Calibri" pitchFamily="34" charset="-122"/>
                 <a:cs typeface="Calibri" pitchFamily="34" charset="-120"/>
               </a:rPr>
-              <a:t>07-02</a:t>
+              <a:t>06-18</a:t>
             </a:r>
             <a:endParaRPr lang="en-US" sz="800" dirty="0"/>
           </a:p>
@@ -4194,13 +4299,13 @@
       </p:sp>
       <p:sp>
         <p:nvSpPr>
-          <p:cNvPr id="45" name="Shape 43"/>
-          <p:cNvSpPr/>
-          <p:nvPr/>
-        </p:nvSpPr>
-        <p:spPr>
-          <a:xfrm>
-            <a:off x="5285232" y="5074920"/>
+          <p:cNvPr id="51" name="Shape 49"/>
+          <p:cNvSpPr/>
+          <p:nvPr/>
+        </p:nvSpPr>
+        <p:spPr>
+          <a:xfrm>
+            <a:off x="3163824" y="6492240"/>
             <a:ext cx="914400" cy="0"/>
           </a:xfrm>
           <a:prstGeom prst="line">
@@ -4217,13 +4322,13 @@
       </p:sp>
       <p:sp>
         <p:nvSpPr>
-          <p:cNvPr id="46" name="Shape 44"/>
-          <p:cNvSpPr/>
-          <p:nvPr/>
-        </p:nvSpPr>
-        <p:spPr>
-          <a:xfrm>
-            <a:off x="6199632" y="5001768"/>
+          <p:cNvPr id="52" name="Shape 50"/>
+          <p:cNvSpPr/>
+          <p:nvPr/>
+        </p:nvSpPr>
+        <p:spPr>
+          <a:xfrm>
+            <a:off x="4078224" y="6419088"/>
             <a:ext cx="146304" cy="146304"/>
           </a:xfrm>
           <a:prstGeom prst="ellipse">
@@ -4237,13 +4342,13 @@
       </p:sp>
       <p:sp>
         <p:nvSpPr>
-          <p:cNvPr id="47" name="Text 45"/>
-          <p:cNvSpPr/>
-          <p:nvPr/>
-        </p:nvSpPr>
-        <p:spPr>
-          <a:xfrm>
-            <a:off x="5971032" y="5212080"/>
+          <p:cNvPr id="53" name="Text 51"/>
+          <p:cNvSpPr/>
+          <p:nvPr/>
+        </p:nvSpPr>
+        <p:spPr>
+          <a:xfrm>
+            <a:off x="3849624" y="6629400"/>
             <a:ext cx="640080" cy="228600"/>
           </a:xfrm>
           <a:prstGeom prst="rect">
@@ -4256,7 +4361,7 @@
           <a:bodyPr wrap="square" rtlCol="0" anchor="ctr"/>
           <a:lstStyle/>
           <a:p>
-            <a:pPr algn="ctr" indent="0" marL="0">
+            <a:pPr marL="0" indent="0" algn="ctr">
               <a:buNone/>
             </a:pPr>
             <a:r>
@@ -4268,6 +4373,170 @@
                 <a:ea typeface="Calibri" pitchFamily="34" charset="-122"/>
                 <a:cs typeface="Calibri" pitchFamily="34" charset="-120"/>
               </a:rPr>
+              <a:t>06-25</a:t>
+            </a:r>
+            <a:endParaRPr lang="en-US" sz="800" dirty="0"/>
+          </a:p>
+        </p:txBody>
+      </p:sp>
+      <p:sp>
+        <p:nvSpPr>
+          <p:cNvPr id="54" name="Shape 52"/>
+          <p:cNvSpPr/>
+          <p:nvPr/>
+        </p:nvSpPr>
+        <p:spPr>
+          <a:xfrm>
+            <a:off x="4224528" y="6492240"/>
+            <a:ext cx="914400" cy="0"/>
+          </a:xfrm>
+          <a:prstGeom prst="line">
+            <a:avLst/>
+          </a:prstGeom>
+          <a:noFill/>
+          <a:ln w="19050">
+            <a:solidFill>
+              <a:srgbClr val="D1D5DB"/>
+            </a:solidFill>
+            <a:prstDash val="solid"/>
+          </a:ln>
+        </p:spPr>
+      </p:sp>
+      <p:sp>
+        <p:nvSpPr>
+          <p:cNvPr id="55" name="Shape 53"/>
+          <p:cNvSpPr/>
+          <p:nvPr/>
+        </p:nvSpPr>
+        <p:spPr>
+          <a:xfrm>
+            <a:off x="5138928" y="6419088"/>
+            <a:ext cx="146304" cy="146304"/>
+          </a:xfrm>
+          <a:prstGeom prst="ellipse">
+            <a:avLst/>
+          </a:prstGeom>
+          <a:solidFill>
+            <a:srgbClr val="2E8B57"/>
+          </a:solidFill>
+          <a:ln/>
+        </p:spPr>
+      </p:sp>
+      <p:sp>
+        <p:nvSpPr>
+          <p:cNvPr id="56" name="Text 54"/>
+          <p:cNvSpPr/>
+          <p:nvPr/>
+        </p:nvSpPr>
+        <p:spPr>
+          <a:xfrm>
+            <a:off x="4910328" y="6629400"/>
+            <a:ext cx="640080" cy="228600"/>
+          </a:xfrm>
+          <a:prstGeom prst="rect">
+            <a:avLst/>
+          </a:prstGeom>
+          <a:noFill/>
+          <a:ln/>
+        </p:spPr>
+        <p:txBody>
+          <a:bodyPr wrap="square" rtlCol="0" anchor="ctr"/>
+          <a:lstStyle/>
+          <a:p>
+            <a:pPr marL="0" indent="0" algn="ctr">
+              <a:buNone/>
+            </a:pPr>
+            <a:r>
+              <a:rPr lang="en-US" sz="800" dirty="0">
+                <a:solidFill>
+                  <a:srgbClr val="6B7280"/>
+                </a:solidFill>
+                <a:latin typeface="Calibri" pitchFamily="34" charset="0"/>
+                <a:ea typeface="Calibri" pitchFamily="34" charset="-122"/>
+                <a:cs typeface="Calibri" pitchFamily="34" charset="-120"/>
+              </a:rPr>
+              <a:t>07-02</a:t>
+            </a:r>
+            <a:endParaRPr lang="en-US" sz="800" dirty="0"/>
+          </a:p>
+        </p:txBody>
+      </p:sp>
+      <p:sp>
+        <p:nvSpPr>
+          <p:cNvPr id="57" name="Shape 55"/>
+          <p:cNvSpPr/>
+          <p:nvPr/>
+        </p:nvSpPr>
+        <p:spPr>
+          <a:xfrm>
+            <a:off x="5285232" y="6492240"/>
+            <a:ext cx="914400" cy="0"/>
+          </a:xfrm>
+          <a:prstGeom prst="line">
+            <a:avLst/>
+          </a:prstGeom>
+          <a:noFill/>
+          <a:ln w="19050">
+            <a:solidFill>
+              <a:srgbClr val="D1D5DB"/>
+            </a:solidFill>
+            <a:prstDash val="solid"/>
+          </a:ln>
+        </p:spPr>
+      </p:sp>
+      <p:sp>
+        <p:nvSpPr>
+          <p:cNvPr id="58" name="Shape 56"/>
+          <p:cNvSpPr/>
+          <p:nvPr/>
+        </p:nvSpPr>
+        <p:spPr>
+          <a:xfrm>
+            <a:off x="6199632" y="6419088"/>
+            <a:ext cx="146304" cy="146304"/>
+          </a:xfrm>
+          <a:prstGeom prst="ellipse">
+            <a:avLst/>
+          </a:prstGeom>
+          <a:solidFill>
+            <a:srgbClr val="2E8B57"/>
+          </a:solidFill>
+          <a:ln/>
+        </p:spPr>
+      </p:sp>
+      <p:sp>
+        <p:nvSpPr>
+          <p:cNvPr id="59" name="Text 57"/>
+          <p:cNvSpPr/>
+          <p:nvPr/>
+        </p:nvSpPr>
+        <p:spPr>
+          <a:xfrm>
+            <a:off x="5971032" y="6629400"/>
+            <a:ext cx="640080" cy="228600"/>
+          </a:xfrm>
+          <a:prstGeom prst="rect">
+            <a:avLst/>
+          </a:prstGeom>
+          <a:noFill/>
+          <a:ln/>
+        </p:spPr>
+        <p:txBody>
+          <a:bodyPr wrap="square" rtlCol="0" anchor="ctr"/>
+          <a:lstStyle/>
+          <a:p>
+            <a:pPr marL="0" indent="0" algn="ctr">
+              <a:buNone/>
+            </a:pPr>
+            <a:r>
+              <a:rPr lang="en-US" sz="800" dirty="0">
+                <a:solidFill>
+                  <a:srgbClr val="6B7280"/>
+                </a:solidFill>
+                <a:latin typeface="Calibri" pitchFamily="34" charset="0"/>
+                <a:ea typeface="Calibri" pitchFamily="34" charset="-122"/>
+                <a:cs typeface="Calibri" pitchFamily="34" charset="-120"/>
+              </a:rPr>
               <a:t>07-09</a:t>
             </a:r>
             <a:endParaRPr lang="en-US" sz="800" dirty="0"/>
@@ -4276,13 +4545,13 @@
       </p:sp>
       <p:sp>
         <p:nvSpPr>
-          <p:cNvPr id="48" name="Text 46"/>
-          <p:cNvSpPr/>
-          <p:nvPr/>
-        </p:nvSpPr>
-        <p:spPr>
-          <a:xfrm>
-            <a:off x="5852160" y="4544568"/>
+          <p:cNvPr id="60" name="Text 58"/>
+          <p:cNvSpPr/>
+          <p:nvPr/>
+        </p:nvSpPr>
+        <p:spPr>
+          <a:xfrm>
+            <a:off x="5852160" y="5961888"/>
             <a:ext cx="5577840" cy="1005840"/>
           </a:xfrm>
           <a:prstGeom prst="rect">
@@ -4295,7 +4564,7 @@
           <a:bodyPr wrap="square" rtlCol="0" anchor="t"/>
           <a:lstStyle/>
           <a:p>
-            <a:pPr indent="0" marL="0">
+            <a:pPr marL="0" indent="0">
               <a:lnSpc>
                 <a:spcPct val="120000"/>
               </a:lnSpc>
@@ -4318,13 +4587,13 @@
       </p:sp>
       <p:sp>
         <p:nvSpPr>
-          <p:cNvPr id="49" name="Text 47"/>
-          <p:cNvSpPr/>
-          <p:nvPr/>
-        </p:nvSpPr>
-        <p:spPr>
-          <a:xfrm>
-            <a:off x="457200" y="6473952"/>
+          <p:cNvPr id="61" name="Text 59"/>
+          <p:cNvSpPr/>
+          <p:nvPr/>
+        </p:nvSpPr>
+        <p:spPr>
+          <a:xfrm>
+            <a:off x="512064" y="1280160"/>
             <a:ext cx="7315200" cy="274320"/>
           </a:xfrm>
           <a:prstGeom prst="rect">
@@ -4337,7 +4606,7 @@
           <a:bodyPr wrap="square" rtlCol="0" anchor="ctr"/>
           <a:lstStyle/>
           <a:p>
-            <a:pPr indent="0" marL="0">
+            <a:pPr marL="0" indent="0">
               <a:buNone/>
             </a:pPr>
             <a:r>
@@ -4357,13 +4626,13 @@
       </p:sp>
       <p:sp>
         <p:nvSpPr>
-          <p:cNvPr id="50" name="Text 48"/>
-          <p:cNvSpPr/>
-          <p:nvPr/>
-        </p:nvSpPr>
-        <p:spPr>
-          <a:xfrm>
-            <a:off x="9601200" y="6473952"/>
+          <p:cNvPr id="62" name="Text 60"/>
+          <p:cNvSpPr/>
+          <p:nvPr/>
+        </p:nvSpPr>
+        <p:spPr>
+          <a:xfrm>
+            <a:off x="9558068" y="1247725"/>
             <a:ext cx="2103120" cy="274320"/>
           </a:xfrm>
           <a:prstGeom prst="rect">
@@ -4376,7 +4645,7 @@
           <a:bodyPr wrap="square" rtlCol="0" anchor="ctr"/>
           <a:lstStyle/>
           <a:p>
-            <a:pPr algn="r" indent="0" marL="0">
+            <a:pPr marL="0" indent="0" algn="r">
               <a:buNone/>
             </a:pPr>
             <a:r>
@@ -4410,6 +4679,7 @@
         <a:solidFill>
           <a:srgbClr val="FFFFFF"/>
         </a:solidFill>
+        <a:effectLst/>
       </p:bgPr>
     </p:bg>
     <p:spTree>
@@ -4447,7 +4717,7 @@
           <a:bodyPr wrap="square" rtlCol="0" anchor="ctr"/>
           <a:lstStyle/>
           <a:p>
-            <a:pPr indent="0" marL="0">
+            <a:pPr marL="0" indent="0">
               <a:buNone/>
             </a:pPr>
             <a:r>
@@ -4486,7 +4756,7 @@
           <a:bodyPr wrap="square" rtlCol="0" anchor="ctr"/>
           <a:lstStyle/>
           <a:p>
-            <a:pPr indent="0" marL="0">
+            <a:pPr marL="0" indent="0">
               <a:buNone/>
             </a:pPr>
             <a:r>
@@ -4506,7 +4776,7 @@
       </p:sp>
       <p:graphicFrame>
         <p:nvGraphicFramePr>
-          <p:cNvPr id="4" name="Chart 0" descr=""/>
+          <p:cNvPr id="4" name="Chart 0"/>
           <p:cNvGraphicFramePr/>
           <p:nvPr/>
         </p:nvGraphicFramePr>
@@ -4514,9 +4784,9 @@
           <a:off x="548640" y="1463040"/>
           <a:ext cx="6400800" cy="4114800"/>
         </p:xfrm>
-        <a:graphic xmlns:a="http://schemas.openxmlformats.org/drawingml/2006/main">
+        <a:graphic>
           <a:graphicData uri="http://schemas.openxmlformats.org/drawingml/2006/chart">
-            <c:chart xmlns:c="http://schemas.openxmlformats.org/drawingml/2006/chart" r:id="rId1"/>
+            <c:chart xmlns:c="http://schemas.openxmlformats.org/drawingml/2006/chart" xmlns:r="http://schemas.openxmlformats.org/officeDocument/2006/relationships" r:id="rId3"/>
           </a:graphicData>
         </a:graphic>
       </p:graphicFrame>
@@ -4563,7 +4833,7 @@
           <a:bodyPr wrap="square" rtlCol="0" anchor="ctr"/>
           <a:lstStyle/>
           <a:p>
-            <a:pPr indent="0" marL="0">
+            <a:pPr marL="0" indent="0">
               <a:buNone/>
             </a:pPr>
             <a:r>
@@ -4687,7 +4957,7 @@
           <a:bodyPr wrap="square" rtlCol="0" anchor="ctr"/>
           <a:lstStyle/>
           <a:p>
-            <a:pPr indent="0" marL="0">
+            <a:pPr marL="0" indent="0">
               <a:buNone/>
             </a:pPr>
             <a:r>
@@ -4726,7 +4996,7 @@
           <a:bodyPr wrap="square" rtlCol="0" anchor="ctr"/>
           <a:lstStyle/>
           <a:p>
-            <a:pPr algn="r" indent="0" marL="0">
+            <a:pPr marL="0" indent="0" algn="r">
               <a:buNone/>
             </a:pPr>
             <a:r>
@@ -4760,6 +5030,7 @@
         <a:solidFill>
           <a:srgbClr val="FFFFFF"/>
         </a:solidFill>
+        <a:effectLst/>
       </p:bgPr>
     </p:bg>
     <p:spTree>
@@ -4797,7 +5068,7 @@
           <a:bodyPr wrap="square" rtlCol="0" anchor="ctr"/>
           <a:lstStyle/>
           <a:p>
-            <a:pPr indent="0" marL="0">
+            <a:pPr marL="0" indent="0">
               <a:buNone/>
             </a:pPr>
             <a:r>
@@ -4880,7 +5151,7 @@
           <a:bodyPr wrap="square" rtlCol="0" anchor="ctr"/>
           <a:lstStyle/>
           <a:p>
-            <a:pPr algn="ctr" indent="0" marL="0">
+            <a:pPr marL="0" indent="0" algn="ctr">
               <a:buNone/>
             </a:pPr>
             <a:r>
@@ -4919,7 +5190,7 @@
           <a:bodyPr wrap="square" rtlCol="0" anchor="ctr"/>
           <a:lstStyle/>
           <a:p>
-            <a:pPr indent="0" marL="0">
+            <a:pPr marL="0" indent="0">
               <a:buNone/>
             </a:pPr>
             <a:r>
@@ -4958,7 +5229,7 @@
           <a:bodyPr wrap="square" rtlCol="0" anchor="ctr"/>
           <a:lstStyle/>
           <a:p>
-            <a:pPr indent="0" marL="0">
+            <a:pPr marL="0" indent="0">
               <a:buNone/>
             </a:pPr>
             <a:r>
@@ -5103,7 +5374,7 @@
           <a:bodyPr wrap="square" rtlCol="0" anchor="t"/>
           <a:lstStyle/>
           <a:p>
-            <a:pPr indent="0" marL="0">
+            <a:pPr marL="0" indent="0">
               <a:lnSpc>
                 <a:spcPct val="125000"/>
               </a:lnSpc>
@@ -5189,7 +5460,7 @@
           <a:bodyPr wrap="square" rtlCol="0" anchor="ctr"/>
           <a:lstStyle/>
           <a:p>
-            <a:pPr algn="ctr" indent="0" marL="0">
+            <a:pPr marL="0" indent="0" algn="ctr">
               <a:buNone/>
             </a:pPr>
             <a:r>
@@ -5228,7 +5499,7 @@
           <a:bodyPr wrap="square" rtlCol="0" anchor="ctr"/>
           <a:lstStyle/>
           <a:p>
-            <a:pPr indent="0" marL="0">
+            <a:pPr marL="0" indent="0">
               <a:buNone/>
             </a:pPr>
             <a:r>
@@ -5240,7 +5511,7 @@
                 <a:ea typeface="Cambria" pitchFamily="34" charset="-122"/>
                 <a:cs typeface="Cambria" pitchFamily="34" charset="-120"/>
               </a:rPr>
-              <a:t>Zycus - UniSan S2P Implementation</a:t>
+              <a:t>Zycus - Titan S2P Implementation</a:t>
             </a:r>
             <a:endParaRPr lang="en-US" sz="1600" dirty="0"/>
           </a:p>
@@ -5267,7 +5538,7 @@
           <a:bodyPr wrap="square" rtlCol="0" anchor="ctr"/>
           <a:lstStyle/>
           <a:p>
-            <a:pPr indent="0" marL="0">
+            <a:pPr marL="0" indent="0">
               <a:buNone/>
             </a:pPr>
             <a:r>
@@ -5279,7 +5550,7 @@
                 <a:ea typeface="Calibri" pitchFamily="34" charset="-122"/>
                 <a:cs typeface="Calibri" pitchFamily="34" charset="-120"/>
               </a:rPr>
-              <a:t>PM: Rajat Bothra</a:t>
+              <a:t>PM: Aftab Hashambhai</a:t>
             </a:r>
             <a:endParaRPr lang="en-US" sz="1100" dirty="0"/>
           </a:p>
@@ -5358,13 +5629,13 @@
             <a:r>
               <a:rPr lang="en-US" sz="1200" dirty="0">
                 <a:solidFill>
-                  <a:srgbClr val="C0392B"/>
-                </a:solidFill>
-                <a:latin typeface="Calibri" pitchFamily="34" charset="0"/>
-                <a:ea typeface="Calibri" pitchFamily="34" charset="-122"/>
-                <a:cs typeface="Calibri" pitchFamily="34" charset="-120"/>
-              </a:rPr>
-              <a:t>Blockers: Red</a:t>
+                  <a:srgbClr val="D9A441"/>
+                </a:solidFill>
+                <a:latin typeface="Calibri" pitchFamily="34" charset="0"/>
+                <a:ea typeface="Calibri" pitchFamily="34" charset="-122"/>
+                <a:cs typeface="Calibri" pitchFamily="34" charset="-120"/>
+              </a:rPr>
+              <a:t>Blockers: Amber</a:t>
             </a:r>
             <a:endParaRPr lang="en-US" sz="1200" dirty="0"/>
           </a:p>
@@ -5391,7 +5662,7 @@
           <a:bodyPr wrap="square" rtlCol="0" anchor="t"/>
           <a:lstStyle/>
           <a:p>
-            <a:pPr indent="0" marL="0">
+            <a:pPr marL="0" indent="0">
               <a:lnSpc>
                 <a:spcPct val="125000"/>
               </a:lnSpc>
@@ -5406,7 +5677,7 @@
                 <a:ea typeface="Calibri" pitchFamily="34" charset="-122"/>
                 <a:cs typeface="Calibri" pitchFamily="34" charset="-120"/>
               </a:rPr>
-              <a:t>Zycus - UniSan S2P Implementation is off track and needs immediate leadership intervention. Schedule: 44 of 234 active tasks (19%) are past their planned end date. 42 tasks (11%) are self-flagged Red in the plan. 3 critical-path tasks are overdue. Actual progress is running at 71% of the pace needed for the elapsed timeline. Milestones: 2 of 39 major phase(s) are past their planned end date and not yet complete (e.g. Training Phase I, Hypercare Phase I). Blockers: 29 dependent task(s) have a passed start date but haven't started (possible blockers). Note: budget, sentiment could not be assessed (data not available in source file) and were excluded from the composite score.</a:t>
+              <a:t>Zycus - Titan S2P Implementation is off track and needs immediate leadership intervention. Schedule: 16 active task(s) are past their planned end date, within tolerance. 82 tasks (17%) are self-flagged Red in the plan. Milestones: 2 of 14 major phase(s) are past their planned end date and not yet complete (e.g. Configuration and Build phase, Production &amp; Cutover). Blockers: 1 dependent task(s) have a passed start date but haven't started (possible blockers). 3 task(s) explicitly marked On Hold. Note: budget could not be assessed (data not available in source file) and were excluded from the composite score.</a:t>
             </a:r>
             <a:endParaRPr lang="en-US" sz="1050" dirty="0"/>
           </a:p>
@@ -5433,7 +5704,7 @@
           <a:bodyPr wrap="square" rtlCol="0" anchor="ctr"/>
           <a:lstStyle/>
           <a:p>
-            <a:pPr indent="0" marL="0">
+            <a:pPr marL="0" indent="0">
               <a:buNone/>
             </a:pPr>
             <a:r>
@@ -5472,7 +5743,7 @@
           <a:bodyPr wrap="square" rtlCol="0" anchor="ctr"/>
           <a:lstStyle/>
           <a:p>
-            <a:pPr algn="r" indent="0" marL="0">
+            <a:pPr marL="0" indent="0" algn="r">
               <a:buNone/>
             </a:pPr>
             <a:r>
@@ -5506,6 +5777,7 @@
         <a:solidFill>
           <a:srgbClr val="1E2761"/>
         </a:solidFill>
+        <a:effectLst/>
       </p:bgPr>
     </p:bg>
     <p:spTree>
@@ -5543,7 +5815,7 @@
           <a:bodyPr wrap="square" rtlCol="0" anchor="ctr"/>
           <a:lstStyle/>
           <a:p>
-            <a:pPr indent="0" marL="0">
+            <a:pPr marL="0" indent="0">
               <a:buNone/>
             </a:pPr>
             <a:r>
@@ -5602,7 +5874,7 @@
           <a:bodyPr wrap="square" rtlCol="0" anchor="ctr"/>
           <a:lstStyle/>
           <a:p>
-            <a:pPr algn="ctr" indent="0" marL="0">
+            <a:pPr marL="0" indent="0" algn="ctr">
               <a:buNone/>
             </a:pPr>
             <a:r>
@@ -5641,7 +5913,7 @@
           <a:bodyPr wrap="square" rtlCol="0" anchor="ctr"/>
           <a:lstStyle/>
           <a:p>
-            <a:pPr indent="0" marL="0">
+            <a:pPr marL="0" indent="0">
               <a:buNone/>
             </a:pPr>
             <a:r>
@@ -5680,7 +5952,7 @@
           <a:bodyPr wrap="square" rtlCol="0" anchor="ctr"/>
           <a:lstStyle/>
           <a:p>
-            <a:pPr indent="0" marL="0">
+            <a:pPr marL="0" indent="0">
               <a:lnSpc>
                 <a:spcPct val="130000"/>
               </a:lnSpc>
@@ -5742,7 +6014,7 @@
           <a:bodyPr wrap="square" rtlCol="0" anchor="ctr"/>
           <a:lstStyle/>
           <a:p>
-            <a:pPr algn="ctr" indent="0" marL="0">
+            <a:pPr marL="0" indent="0" algn="ctr">
               <a:buNone/>
             </a:pPr>
             <a:r>
@@ -5781,7 +6053,7 @@
           <a:bodyPr wrap="square" rtlCol="0" anchor="ctr"/>
           <a:lstStyle/>
           <a:p>
-            <a:pPr indent="0" marL="0">
+            <a:pPr marL="0" indent="0">
               <a:buNone/>
             </a:pPr>
             <a:r>
@@ -5820,7 +6092,7 @@
           <a:bodyPr wrap="square" rtlCol="0" anchor="ctr"/>
           <a:lstStyle/>
           <a:p>
-            <a:pPr indent="0" marL="0">
+            <a:pPr marL="0" indent="0">
               <a:lnSpc>
                 <a:spcPct val="130000"/>
               </a:lnSpc>
@@ -5882,7 +6154,7 @@
           <a:bodyPr wrap="square" rtlCol="0" anchor="ctr"/>
           <a:lstStyle/>
           <a:p>
-            <a:pPr algn="ctr" indent="0" marL="0">
+            <a:pPr marL="0" indent="0" algn="ctr">
               <a:buNone/>
             </a:pPr>
             <a:r>
@@ -5921,7 +6193,7 @@
           <a:bodyPr wrap="square" rtlCol="0" anchor="ctr"/>
           <a:lstStyle/>
           <a:p>
-            <a:pPr indent="0" marL="0">
+            <a:pPr marL="0" indent="0">
               <a:buNone/>
             </a:pPr>
             <a:r>
@@ -5960,7 +6232,7 @@
           <a:bodyPr wrap="square" rtlCol="0" anchor="ctr"/>
           <a:lstStyle/>
           <a:p>
-            <a:pPr indent="0" marL="0">
+            <a:pPr marL="0" indent="0">
               <a:lnSpc>
                 <a:spcPct val="130000"/>
               </a:lnSpc>
@@ -6002,7 +6274,7 @@
           <a:bodyPr wrap="square" rtlCol="0" anchor="ctr"/>
           <a:lstStyle/>
           <a:p>
-            <a:pPr indent="0" marL="0">
+            <a:pPr marL="0" indent="0">
               <a:buNone/>
             </a:pPr>
             <a:r>
@@ -6321,4 +6593,299 @@
     </a:ext>
   </a:extLst>
 </a:theme>
+</file>
+
+<file path=ppt/theme/theme2.xml><?xml version="1.0" encoding="utf-8"?>
+<a:theme xmlns:a="http://schemas.openxmlformats.org/drawingml/2006/main" name="Office Theme">
+  <a:themeElements>
+    <a:clrScheme name="Office">
+      <a:dk1>
+        <a:sysClr val="windowText" lastClr="000000"/>
+      </a:dk1>
+      <a:lt1>
+        <a:sysClr val="window" lastClr="FFFFFF"/>
+      </a:lt1>
+      <a:dk2>
+        <a:srgbClr val="44546A"/>
+      </a:dk2>
+      <a:lt2>
+        <a:srgbClr val="E7E6E6"/>
+      </a:lt2>
+      <a:accent1>
+        <a:srgbClr val="4472C4"/>
+      </a:accent1>
+      <a:accent2>
+        <a:srgbClr val="ED7D31"/>
+      </a:accent2>
+      <a:accent3>
+        <a:srgbClr val="A5A5A5"/>
+      </a:accent3>
+      <a:accent4>
+        <a:srgbClr val="FFC000"/>
+      </a:accent4>
+      <a:accent5>
+        <a:srgbClr val="5B9BD5"/>
+      </a:accent5>
+      <a:accent6>
+        <a:srgbClr val="70AD47"/>
+      </a:accent6>
+      <a:hlink>
+        <a:srgbClr val="0563C1"/>
+      </a:hlink>
+      <a:folHlink>
+        <a:srgbClr val="954F72"/>
+      </a:folHlink>
+    </a:clrScheme>
+    <a:fontScheme name="Office">
+      <a:majorFont>
+        <a:latin typeface="Calibri Light" panose="020F0302020204030204"/>
+        <a:ea typeface=""/>
+        <a:cs typeface=""/>
+        <a:font script="Jpan" typeface="游ゴシック Light"/>
+        <a:font script="Hang" typeface="맑은 고딕"/>
+        <a:font script="Hans" typeface="等线 Light"/>
+        <a:font script="Hant" typeface="新細明體"/>
+        <a:font script="Arab" typeface="Times New Roman"/>
+        <a:font script="Hebr" typeface="Times New Roman"/>
+        <a:font script="Thai" typeface="Angsana New"/>
+        <a:font script="Ethi" typeface="Nyala"/>
+        <a:font script="Beng" typeface="Vrinda"/>
+        <a:font script="Gujr" typeface="Shruti"/>
+        <a:font script="Khmr" typeface="MoolBoran"/>
+        <a:font script="Knda" typeface="Tunga"/>
+        <a:font script="Guru" typeface="Raavi"/>
+        <a:font script="Cans" typeface="Euphemia"/>
+        <a:font script="Cher" typeface="Plantagenet Cherokee"/>
+        <a:font script="Yiii" typeface="Microsoft Yi Baiti"/>
+        <a:font script="Tibt" typeface="Microsoft Himalaya"/>
+        <a:font script="Thaa" typeface="MV Boli"/>
+        <a:font script="Deva" typeface="Mangal"/>
+        <a:font script="Telu" typeface="Gautami"/>
+        <a:font script="Taml" typeface="Latha"/>
+        <a:font script="Syrc" typeface="Estrangelo Edessa"/>
+        <a:font script="Orya" typeface="Kalinga"/>
+        <a:font script="Mlym" typeface="Kartika"/>
+        <a:font script="Laoo" typeface="DokChampa"/>
+        <a:font script="Sinh" typeface="Iskoola Pota"/>
+        <a:font script="Mong" typeface="Mongolian Baiti"/>
+        <a:font script="Viet" typeface="Times New Roman"/>
+        <a:font script="Uigh" typeface="Microsoft Uighur"/>
+        <a:font script="Geor" typeface="Sylfaen"/>
+        <a:font script="Armn" typeface="Arial"/>
+        <a:font script="Bugi" typeface="Leelawadee UI"/>
+        <a:font script="Bopo" typeface="Microsoft JhengHei"/>
+        <a:font script="Java" typeface="Javanese Text"/>
+        <a:font script="Lisu" typeface="Segoe UI"/>
+        <a:font script="Mymr" typeface="Myanmar Text"/>
+        <a:font script="Nkoo" typeface="Ebrima"/>
+        <a:font script="Olck" typeface="Nirmala UI"/>
+        <a:font script="Osma" typeface="Ebrima"/>
+        <a:font script="Phag" typeface="Phagspa"/>
+        <a:font script="Syrn" typeface="Estrangelo Edessa"/>
+        <a:font script="Syrj" typeface="Estrangelo Edessa"/>
+        <a:font script="Syre" typeface="Estrangelo Edessa"/>
+        <a:font script="Sora" typeface="Nirmala UI"/>
+        <a:font script="Tale" typeface="Microsoft Tai Le"/>
+        <a:font script="Talu" typeface="Microsoft New Tai Lue"/>
+        <a:font script="Tfng" typeface="Ebrima"/>
+      </a:majorFont>
+      <a:minorFont>
+        <a:latin typeface="Calibri" panose="020F0502020204030204"/>
+        <a:ea typeface=""/>
+        <a:cs typeface=""/>
+        <a:font script="Jpan" typeface="游ゴシック"/>
+        <a:font script="Hang" typeface="맑은 고딕"/>
+        <a:font script="Hans" typeface="等线"/>
+        <a:font script="Hant" typeface="新細明體"/>
+        <a:font script="Arab" typeface="Arial"/>
+        <a:font script="Hebr" typeface="Arial"/>
+        <a:font script="Thai" typeface="Cordia New"/>
+        <a:font script="Ethi" typeface="Nyala"/>
+        <a:font script="Beng" typeface="Vrinda"/>
+        <a:font script="Gujr" typeface="Shruti"/>
+        <a:font script="Khmr" typeface="DaunPenh"/>
+        <a:font script="Knda" typeface="Tunga"/>
+        <a:font script="Guru" typeface="Raavi"/>
+        <a:font script="Cans" typeface="Euphemia"/>
+        <a:font script="Cher" typeface="Plantagenet Cherokee"/>
+        <a:font script="Yiii" typeface="Microsoft Yi Baiti"/>
+        <a:font script="Tibt" typeface="Microsoft Himalaya"/>
+        <a:font script="Thaa" typeface="MV Boli"/>
+        <a:font script="Deva" typeface="Mangal"/>
+        <a:font script="Telu" typeface="Gautami"/>
+        <a:font script="Taml" typeface="Latha"/>
+        <a:font script="Syrc" typeface="Estrangelo Edessa"/>
+        <a:font script="Orya" typeface="Kalinga"/>
+        <a:font script="Mlym" typeface="Kartika"/>
+        <a:font script="Laoo" typeface="DokChampa"/>
+        <a:font script="Sinh" typeface="Iskoola Pota"/>
+        <a:font script="Mong" typeface="Mongolian Baiti"/>
+        <a:font script="Viet" typeface="Arial"/>
+        <a:font script="Uigh" typeface="Microsoft Uighur"/>
+        <a:font script="Geor" typeface="Sylfaen"/>
+        <a:font script="Armn" typeface="Arial"/>
+        <a:font script="Bugi" typeface="Leelawadee UI"/>
+        <a:font script="Bopo" typeface="Microsoft JhengHei"/>
+        <a:font script="Java" typeface="Javanese Text"/>
+        <a:font script="Lisu" typeface="Segoe UI"/>
+        <a:font script="Mymr" typeface="Myanmar Text"/>
+        <a:font script="Nkoo" typeface="Ebrima"/>
+        <a:font script="Olck" typeface="Nirmala UI"/>
+        <a:font script="Osma" typeface="Ebrima"/>
+        <a:font script="Phag" typeface="Phagspa"/>
+        <a:font script="Syrn" typeface="Estrangelo Edessa"/>
+        <a:font script="Syrj" typeface="Estrangelo Edessa"/>
+        <a:font script="Syre" typeface="Estrangelo Edessa"/>
+        <a:font script="Sora" typeface="Nirmala UI"/>
+        <a:font script="Tale" typeface="Microsoft Tai Le"/>
+        <a:font script="Talu" typeface="Microsoft New Tai Lue"/>
+        <a:font script="Tfng" typeface="Ebrima"/>
+      </a:minorFont>
+    </a:fontScheme>
+    <a:fmtScheme name="Office">
+      <a:fillStyleLst>
+        <a:solidFill>
+          <a:schemeClr val="phClr"/>
+        </a:solidFill>
+        <a:gradFill rotWithShape="1">
+          <a:gsLst>
+            <a:gs pos="0">
+              <a:schemeClr val="phClr">
+                <a:lumMod val="110000"/>
+                <a:satMod val="105000"/>
+                <a:tint val="67000"/>
+              </a:schemeClr>
+            </a:gs>
+            <a:gs pos="50000">
+              <a:schemeClr val="phClr">
+                <a:lumMod val="105000"/>
+                <a:satMod val="103000"/>
+                <a:tint val="73000"/>
+              </a:schemeClr>
+            </a:gs>
+            <a:gs pos="100000">
+              <a:schemeClr val="phClr">
+                <a:lumMod val="105000"/>
+                <a:satMod val="109000"/>
+                <a:tint val="81000"/>
+              </a:schemeClr>
+            </a:gs>
+          </a:gsLst>
+          <a:lin ang="5400000" scaled="0"/>
+        </a:gradFill>
+        <a:gradFill rotWithShape="1">
+          <a:gsLst>
+            <a:gs pos="0">
+              <a:schemeClr val="phClr">
+                <a:satMod val="103000"/>
+                <a:lumMod val="102000"/>
+                <a:tint val="94000"/>
+              </a:schemeClr>
+            </a:gs>
+            <a:gs pos="50000">
+              <a:schemeClr val="phClr">
+                <a:satMod val="110000"/>
+                <a:lumMod val="100000"/>
+                <a:shade val="100000"/>
+              </a:schemeClr>
+            </a:gs>
+            <a:gs pos="100000">
+              <a:schemeClr val="phClr">
+                <a:lumMod val="99000"/>
+                <a:satMod val="120000"/>
+                <a:shade val="78000"/>
+              </a:schemeClr>
+            </a:gs>
+          </a:gsLst>
+          <a:lin ang="5400000" scaled="0"/>
+        </a:gradFill>
+      </a:fillStyleLst>
+      <a:lnStyleLst>
+        <a:ln w="6350" cap="flat" cmpd="sng" algn="ctr">
+          <a:solidFill>
+            <a:schemeClr val="phClr"/>
+          </a:solidFill>
+          <a:prstDash val="solid"/>
+          <a:miter lim="800000"/>
+        </a:ln>
+        <a:ln w="12700" cap="flat" cmpd="sng" algn="ctr">
+          <a:solidFill>
+            <a:schemeClr val="phClr"/>
+          </a:solidFill>
+          <a:prstDash val="solid"/>
+          <a:miter lim="800000"/>
+        </a:ln>
+        <a:ln w="19050" cap="flat" cmpd="sng" algn="ctr">
+          <a:solidFill>
+            <a:schemeClr val="phClr"/>
+          </a:solidFill>
+          <a:prstDash val="solid"/>
+          <a:miter lim="800000"/>
+        </a:ln>
+      </a:lnStyleLst>
+      <a:effectStyleLst>
+        <a:effectStyle>
+          <a:effectLst/>
+        </a:effectStyle>
+        <a:effectStyle>
+          <a:effectLst/>
+        </a:effectStyle>
+        <a:effectStyle>
+          <a:effectLst>
+            <a:outerShdw blurRad="57150" dist="19050" dir="5400000" algn="ctr" rotWithShape="0">
+              <a:srgbClr val="000000">
+                <a:alpha val="63000"/>
+              </a:srgbClr>
+            </a:outerShdw>
+          </a:effectLst>
+        </a:effectStyle>
+      </a:effectStyleLst>
+      <a:bgFillStyleLst>
+        <a:solidFill>
+          <a:schemeClr val="phClr"/>
+        </a:solidFill>
+        <a:solidFill>
+          <a:schemeClr val="phClr">
+            <a:tint val="95000"/>
+            <a:satMod val="170000"/>
+          </a:schemeClr>
+        </a:solidFill>
+        <a:gradFill rotWithShape="1">
+          <a:gsLst>
+            <a:gs pos="0">
+              <a:schemeClr val="phClr">
+                <a:tint val="93000"/>
+                <a:satMod val="150000"/>
+                <a:shade val="98000"/>
+                <a:lumMod val="102000"/>
+              </a:schemeClr>
+            </a:gs>
+            <a:gs pos="50000">
+              <a:schemeClr val="phClr">
+                <a:tint val="98000"/>
+                <a:satMod val="130000"/>
+                <a:shade val="90000"/>
+                <a:lumMod val="103000"/>
+              </a:schemeClr>
+            </a:gs>
+            <a:gs pos="100000">
+              <a:schemeClr val="phClr">
+                <a:shade val="63000"/>
+                <a:satMod val="120000"/>
+              </a:schemeClr>
+            </a:gs>
+          </a:gsLst>
+          <a:lin ang="5400000" scaled="0"/>
+        </a:gradFill>
+      </a:bgFillStyleLst>
+    </a:fmtScheme>
+  </a:themeElements>
+  <a:objectDefaults/>
+  <a:extraClrSchemeLst/>
+  <a:extLst>
+    <a:ext uri="{05A4C25C-085E-4340-85A3-A5531E510DB2}">
+      <thm15:themeFamily xmlns:thm15="http://schemas.microsoft.com/office/thememl/2012/main" name="Office Theme" id="{62F939B6-93AF-4DB8-9C6B-D6C7DFDC589F}" vid="{4A3C46E8-61CC-4603-A589-7422A47A8E4A}"/>
+    </a:ext>
+  </a:extLst>
+</a:theme>
 </file>
</xml_diff>